<commit_message>
chore(results): sync figures, tables and scripts with the analysis directory
Brings the September revisions into the repository: geometric-null direction
figures and tables (script 214), English multiscale and protected-area figures,
regenerated projection figures, and the package scripts 205-216.
</commit_message>
<xml_diff>
--- a/figures/Fig4_random_structure_v2.pptx
+++ b/figures/Fig4_random_structure_v2.pptx
@@ -2223,9 +2223,9 @@
         <p:grpSpPr>
           <a:xfrm>
             <a:off x="182880" y="182880"/>
-            <a:ext cx="11430000" cy="4023360"/>
+            <a:ext cx="9144000" cy="3566160"/>
             <a:chOff x="182880" y="182880"/>
-            <a:chExt cx="11430000" cy="4023360"/>
+            <a:chExt cx="9144000" cy="3566160"/>
           </a:xfrm>
         </p:grpSpPr>
         <p:sp>
@@ -2237,7 +2237,7 @@
           <p:spPr>
             <a:xfrm>
               <a:off x="182880" y="182880"/>
-              <a:ext cx="11430000" cy="4023360"/>
+              <a:ext cx="9144000" cy="3566160"/>
             </a:xfrm>
             <a:prstGeom prst="rect">
               <a:avLst/>
@@ -2272,7 +2272,7 @@
           <p:spPr>
             <a:xfrm>
               <a:off x="182880" y="182880"/>
-              <a:ext cx="11429999" cy="4023360"/>
+              <a:ext cx="9143999" cy="3566160"/>
             </a:xfrm>
             <a:prstGeom prst="rect">
               <a:avLst/>
@@ -2307,7 +2307,7 @@
           <p:spPr>
             <a:xfrm>
               <a:off x="252469" y="252469"/>
-              <a:ext cx="3274871" cy="3884181"/>
+              <a:ext cx="2457856" cy="3426981"/>
             </a:xfrm>
             <a:prstGeom prst="rect">
               <a:avLst/>
@@ -2317,7 +2317,7 @@
                 <a:alpha val="100000"/>
               </a:srgbClr>
             </a:solidFill>
-            <a:ln w="11086" cap="rnd">
+            <a:ln w="12318" cap="rnd">
               <a:solidFill>
                 <a:srgbClr val="FFFFFF">
                   <a:alpha val="100000"/>
@@ -2341,8 +2341,8 @@
           </p:nvSpPr>
           <p:spPr>
             <a:xfrm>
-              <a:off x="3527340" y="252469"/>
-              <a:ext cx="3249450" cy="3884181"/>
+              <a:off x="2710325" y="252469"/>
+              <a:ext cx="2429601" cy="3426981"/>
             </a:xfrm>
             <a:prstGeom prst="rect">
               <a:avLst/>
@@ -2352,7 +2352,7 @@
                 <a:alpha val="100000"/>
               </a:srgbClr>
             </a:solidFill>
-            <a:ln w="11086" cap="rnd">
+            <a:ln w="12318" cap="rnd">
               <a:solidFill>
                 <a:srgbClr val="FFFFFF">
                   <a:alpha val="100000"/>
@@ -2376,8 +2376,8 @@
           </p:nvSpPr>
           <p:spPr>
             <a:xfrm>
-              <a:off x="6776790" y="252469"/>
-              <a:ext cx="4766500" cy="3884181"/>
+              <a:off x="5139927" y="252469"/>
+              <a:ext cx="4117363" cy="3426981"/>
             </a:xfrm>
             <a:prstGeom prst="rect">
               <a:avLst/>
@@ -2387,7 +2387,7 @@
                 <a:alpha val="100000"/>
               </a:srgbClr>
             </a:solidFill>
-            <a:ln w="11086" cap="rnd">
+            <a:ln w="12318" cap="rnd">
               <a:solidFill>
                 <a:srgbClr val="FFFFFF">
                   <a:alpha val="100000"/>
@@ -2411,8 +2411,8 @@
           </p:nvSpPr>
           <p:spPr>
             <a:xfrm>
-              <a:off x="691444" y="656226"/>
-              <a:ext cx="2734675" cy="2853344"/>
+              <a:off x="729470" y="680766"/>
+              <a:ext cx="1879635" cy="2309014"/>
             </a:xfrm>
             <a:prstGeom prst="rect">
               <a:avLst/>
@@ -2437,21 +2437,21 @@
           </p:nvSpPr>
           <p:spPr>
             <a:xfrm>
-              <a:off x="691444" y="3379873"/>
-              <a:ext cx="2734675" cy="0"/>
+              <a:off x="729470" y="2884825"/>
+              <a:ext cx="1879635" cy="0"/>
             </a:xfrm>
             <a:custGeom>
               <a:avLst/>
               <a:pathLst>
-                <a:path w="2734675" h="0">
+                <a:path w="1879635" h="0">
                   <a:moveTo>
                     <a:pt x="0" y="0"/>
                   </a:moveTo>
                   <a:lnTo>
-                    <a:pt x="2734675" y="0"/>
+                    <a:pt x="1879635" y="0"/>
                   </a:lnTo>
                   <a:lnTo>
-                    <a:pt x="2734675" y="0"/>
+                    <a:pt x="1879635" y="0"/>
                   </a:lnTo>
                 </a:path>
               </a:pathLst>
@@ -2480,21 +2480,21 @@
           </p:nvSpPr>
           <p:spPr>
             <a:xfrm>
-              <a:off x="691444" y="2584866"/>
-              <a:ext cx="2734675" cy="0"/>
+              <a:off x="729470" y="2241481"/>
+              <a:ext cx="1879635" cy="0"/>
             </a:xfrm>
             <a:custGeom>
               <a:avLst/>
               <a:pathLst>
-                <a:path w="2734675" h="0">
+                <a:path w="1879635" h="0">
                   <a:moveTo>
                     <a:pt x="0" y="0"/>
                   </a:moveTo>
                   <a:lnTo>
-                    <a:pt x="2734675" y="0"/>
+                    <a:pt x="1879635" y="0"/>
                   </a:lnTo>
                   <a:lnTo>
-                    <a:pt x="2734675" y="0"/>
+                    <a:pt x="1879635" y="0"/>
                   </a:lnTo>
                 </a:path>
               </a:pathLst>
@@ -2523,21 +2523,21 @@
           </p:nvSpPr>
           <p:spPr>
             <a:xfrm>
-              <a:off x="691444" y="1789859"/>
-              <a:ext cx="2734675" cy="0"/>
+              <a:off x="729470" y="1598137"/>
+              <a:ext cx="1879635" cy="0"/>
             </a:xfrm>
             <a:custGeom>
               <a:avLst/>
               <a:pathLst>
-                <a:path w="2734675" h="0">
+                <a:path w="1879635" h="0">
                   <a:moveTo>
                     <a:pt x="0" y="0"/>
                   </a:moveTo>
                   <a:lnTo>
-                    <a:pt x="2734675" y="0"/>
+                    <a:pt x="1879635" y="0"/>
                   </a:lnTo>
                   <a:lnTo>
-                    <a:pt x="2734675" y="0"/>
+                    <a:pt x="1879635" y="0"/>
                   </a:lnTo>
                 </a:path>
               </a:pathLst>
@@ -2566,21 +2566,21 @@
           </p:nvSpPr>
           <p:spPr>
             <a:xfrm>
-              <a:off x="691444" y="994852"/>
-              <a:ext cx="2734675" cy="0"/>
+              <a:off x="729470" y="954792"/>
+              <a:ext cx="1879635" cy="0"/>
             </a:xfrm>
             <a:custGeom>
               <a:avLst/>
               <a:pathLst>
-                <a:path w="2734675" h="0">
+                <a:path w="1879635" h="0">
                   <a:moveTo>
                     <a:pt x="0" y="0"/>
                   </a:moveTo>
                   <a:lnTo>
-                    <a:pt x="2734675" y="0"/>
+                    <a:pt x="1879635" y="0"/>
                   </a:lnTo>
                   <a:lnTo>
-                    <a:pt x="2734675" y="0"/>
+                    <a:pt x="1879635" y="0"/>
                   </a:lnTo>
                 </a:path>
               </a:pathLst>
@@ -2609,8 +2609,8 @@
           </p:nvSpPr>
           <p:spPr>
             <a:xfrm>
-              <a:off x="812740" y="785924"/>
-              <a:ext cx="286699" cy="2593949"/>
+              <a:off x="812841" y="785721"/>
+              <a:ext cx="197058" cy="2099103"/>
             </a:xfrm>
             <a:prstGeom prst="rect">
               <a:avLst/>
@@ -2635,8 +2635,8 @@
           </p:nvSpPr>
           <p:spPr>
             <a:xfrm>
-              <a:off x="1253816" y="1810529"/>
-              <a:ext cx="286699" cy="1569343"/>
+              <a:off x="1116008" y="1614863"/>
+              <a:ext cx="197058" cy="1269961"/>
             </a:xfrm>
             <a:prstGeom prst="rect">
               <a:avLst/>
@@ -2661,8 +2661,8 @@
           </p:nvSpPr>
           <p:spPr>
             <a:xfrm>
-              <a:off x="1694893" y="2190224"/>
-              <a:ext cx="286699" cy="1189648"/>
+              <a:off x="1419175" y="1922125"/>
+              <a:ext cx="197058" cy="962700"/>
             </a:xfrm>
             <a:prstGeom prst="rect">
               <a:avLst/>
@@ -2687,8 +2687,8 @@
           </p:nvSpPr>
           <p:spPr>
             <a:xfrm>
-              <a:off x="2135970" y="3296397"/>
-              <a:ext cx="286699" cy="83475"/>
+              <a:off x="1722342" y="2817274"/>
+              <a:ext cx="197058" cy="67551"/>
             </a:xfrm>
             <a:prstGeom prst="rect">
               <a:avLst/>
@@ -2713,8 +2713,8 @@
           </p:nvSpPr>
           <p:spPr>
             <a:xfrm>
-              <a:off x="2577047" y="3308640"/>
-              <a:ext cx="286699" cy="71232"/>
+              <a:off x="2025509" y="2827181"/>
+              <a:ext cx="197058" cy="57643"/>
             </a:xfrm>
             <a:prstGeom prst="rect">
               <a:avLst/>
@@ -2739,8 +2739,8 @@
           </p:nvSpPr>
           <p:spPr>
             <a:xfrm>
-              <a:off x="3018123" y="3379873"/>
-              <a:ext cx="286699" cy="0"/>
+              <a:off x="2328676" y="2884825"/>
+              <a:ext cx="197058" cy="0"/>
             </a:xfrm>
             <a:prstGeom prst="rect">
               <a:avLst/>
@@ -2765,8 +2765,8 @@
           </p:nvSpPr>
           <p:spPr>
             <a:xfrm>
-              <a:off x="843161" y="688952"/>
-              <a:ext cx="225856" cy="64648"/>
+              <a:off x="782805" y="675308"/>
+              <a:ext cx="257129" cy="73609"/>
             </a:xfrm>
             <a:prstGeom prst="rect">
               <a:avLst/>
@@ -2786,7 +2786,7 @@
                 </a:spcAft>
               </a:pPr>
               <a:r>
-                <a:rPr sz="711" i="0" b="0">
+                <a:rPr sz="810" i="0" b="0">
                   <a:solidFill>
                     <a:srgbClr val="333333">
                       <a:alpha val="100000"/>
@@ -2808,8 +2808,8 @@
           </p:nvSpPr>
           <p:spPr>
             <a:xfrm>
-              <a:off x="1309338" y="1713557"/>
-              <a:ext cx="175656" cy="64648"/>
+              <a:off x="1114547" y="1504450"/>
+              <a:ext cx="199979" cy="73609"/>
             </a:xfrm>
             <a:prstGeom prst="rect">
               <a:avLst/>
@@ -2829,7 +2829,7 @@
                 </a:spcAft>
               </a:pPr>
               <a:r>
-                <a:rPr sz="711" i="0" b="0">
+                <a:rPr sz="810" i="0" b="0">
                   <a:solidFill>
                     <a:srgbClr val="333333">
                       <a:alpha val="100000"/>
@@ -2851,8 +2851,8 @@
           </p:nvSpPr>
           <p:spPr>
             <a:xfrm>
-              <a:off x="1750415" y="2093252"/>
-              <a:ext cx="175656" cy="64648"/>
+              <a:off x="1417714" y="1811711"/>
+              <a:ext cx="199979" cy="73609"/>
             </a:xfrm>
             <a:prstGeom prst="rect">
               <a:avLst/>
@@ -2872,7 +2872,7 @@
                 </a:spcAft>
               </a:pPr>
               <a:r>
-                <a:rPr sz="711" i="0" b="0">
+                <a:rPr sz="810" i="0" b="0">
                   <a:solidFill>
                     <a:srgbClr val="333333">
                       <a:alpha val="100000"/>
@@ -2894,8 +2894,8 @@
           </p:nvSpPr>
           <p:spPr>
             <a:xfrm>
-              <a:off x="2216592" y="3199425"/>
-              <a:ext cx="125455" cy="64648"/>
+              <a:off x="1749456" y="2706860"/>
+              <a:ext cx="142829" cy="73609"/>
             </a:xfrm>
             <a:prstGeom prst="rect">
               <a:avLst/>
@@ -2915,7 +2915,7 @@
                 </a:spcAft>
               </a:pPr>
               <a:r>
-                <a:rPr sz="711" i="0" b="0">
+                <a:rPr sz="810" i="0" b="0">
                   <a:solidFill>
                     <a:srgbClr val="333333">
                       <a:alpha val="100000"/>
@@ -2937,8 +2937,8 @@
           </p:nvSpPr>
           <p:spPr>
             <a:xfrm>
-              <a:off x="2657669" y="3211668"/>
-              <a:ext cx="125455" cy="64648"/>
+              <a:off x="2052623" y="2716768"/>
+              <a:ext cx="142829" cy="73609"/>
             </a:xfrm>
             <a:prstGeom prst="rect">
               <a:avLst/>
@@ -2958,7 +2958,7 @@
                 </a:spcAft>
               </a:pPr>
               <a:r>
-                <a:rPr sz="711" i="0" b="0">
+                <a:rPr sz="810" i="0" b="0">
                   <a:solidFill>
                     <a:srgbClr val="333333">
                       <a:alpha val="100000"/>
@@ -2980,8 +2980,8 @@
           </p:nvSpPr>
           <p:spPr>
             <a:xfrm>
-              <a:off x="3098745" y="3282901"/>
-              <a:ext cx="125455" cy="64648"/>
+              <a:off x="2355790" y="2774411"/>
+              <a:ext cx="142829" cy="73609"/>
             </a:xfrm>
             <a:prstGeom prst="rect">
               <a:avLst/>
@@ -3001,7 +3001,7 @@
                 </a:spcAft>
               </a:pPr>
               <a:r>
-                <a:rPr sz="711" i="0" b="0">
+                <a:rPr sz="810" i="0" b="0">
                   <a:solidFill>
                     <a:srgbClr val="333333">
                       <a:alpha val="100000"/>
@@ -3023,15 +3023,15 @@
           </p:nvSpPr>
           <p:spPr>
             <a:xfrm>
-              <a:off x="691444" y="656226"/>
-              <a:ext cx="0" cy="2853344"/>
+              <a:off x="729470" y="680766"/>
+              <a:ext cx="0" cy="2309014"/>
             </a:xfrm>
             <a:custGeom>
               <a:avLst/>
               <a:pathLst>
-                <a:path w="0" h="2853344">
+                <a:path w="0" h="2309014">
                   <a:moveTo>
-                    <a:pt x="0" y="2853344"/>
+                    <a:pt x="0" y="2309014"/>
                   </a:moveTo>
                   <a:lnTo>
                     <a:pt x="0" y="0"/>
@@ -3063,8 +3063,8 @@
           </p:nvSpPr>
           <p:spPr>
             <a:xfrm>
-              <a:off x="589452" y="3347183"/>
-              <a:ext cx="50749" cy="65379"/>
+              <a:off x="616023" y="2848432"/>
+              <a:ext cx="56509" cy="72786"/>
             </a:xfrm>
             <a:prstGeom prst="rect">
               <a:avLst/>
@@ -3084,7 +3084,7 @@
                 </a:spcAft>
               </a:pPr>
               <a:r>
-                <a:rPr sz="720" i="0" b="0">
+                <a:rPr sz="800" i="0" b="0">
                   <a:solidFill>
                     <a:srgbClr val="262626">
                       <a:alpha val="100000"/>
@@ -3106,8 +3106,8 @@
           </p:nvSpPr>
           <p:spPr>
             <a:xfrm>
-              <a:off x="538702" y="2552176"/>
-              <a:ext cx="101498" cy="65379"/>
+              <a:off x="559514" y="2205088"/>
+              <a:ext cx="113019" cy="72786"/>
             </a:xfrm>
             <a:prstGeom prst="rect">
               <a:avLst/>
@@ -3127,7 +3127,7 @@
                 </a:spcAft>
               </a:pPr>
               <a:r>
-                <a:rPr sz="720" i="0" b="0">
+                <a:rPr sz="800" i="0" b="0">
                   <a:solidFill>
                     <a:srgbClr val="262626">
                       <a:alpha val="100000"/>
@@ -3149,8 +3149,8 @@
           </p:nvSpPr>
           <p:spPr>
             <a:xfrm>
-              <a:off x="487953" y="1757169"/>
-              <a:ext cx="152247" cy="65379"/>
+              <a:off x="503004" y="1561743"/>
+              <a:ext cx="169529" cy="72786"/>
             </a:xfrm>
             <a:prstGeom prst="rect">
               <a:avLst/>
@@ -3170,7 +3170,7 @@
                 </a:spcAft>
               </a:pPr>
               <a:r>
-                <a:rPr sz="720" i="0" b="0">
+                <a:rPr sz="800" i="0" b="0">
                   <a:solidFill>
                     <a:srgbClr val="262626">
                       <a:alpha val="100000"/>
@@ -3192,8 +3192,8 @@
           </p:nvSpPr>
           <p:spPr>
             <a:xfrm>
-              <a:off x="487953" y="962162"/>
-              <a:ext cx="152247" cy="65379"/>
+              <a:off x="503004" y="918399"/>
+              <a:ext cx="169529" cy="72786"/>
             </a:xfrm>
             <a:prstGeom prst="rect">
               <a:avLst/>
@@ -3213,7 +3213,7 @@
                 </a:spcAft>
               </a:pPr>
               <a:r>
-                <a:rPr sz="720" i="0" b="0">
+                <a:rPr sz="800" i="0" b="0">
                   <a:solidFill>
                     <a:srgbClr val="262626">
                       <a:alpha val="100000"/>
@@ -3235,18 +3235,18 @@
           </p:nvSpPr>
           <p:spPr>
             <a:xfrm>
-              <a:off x="662975" y="3379873"/>
-              <a:ext cx="28468" cy="0"/>
+              <a:off x="697838" y="2884825"/>
+              <a:ext cx="31631" cy="0"/>
             </a:xfrm>
             <a:custGeom>
               <a:avLst/>
               <a:pathLst>
-                <a:path w="28468" h="0">
+                <a:path w="31631" h="0">
                   <a:moveTo>
                     <a:pt x="0" y="0"/>
                   </a:moveTo>
                   <a:lnTo>
-                    <a:pt x="28468" y="0"/>
+                    <a:pt x="31631" y="0"/>
                   </a:lnTo>
                 </a:path>
               </a:pathLst>
@@ -3275,18 +3275,18 @@
           </p:nvSpPr>
           <p:spPr>
             <a:xfrm>
-              <a:off x="662975" y="2584866"/>
-              <a:ext cx="28468" cy="0"/>
+              <a:off x="697838" y="2241481"/>
+              <a:ext cx="31631" cy="0"/>
             </a:xfrm>
             <a:custGeom>
               <a:avLst/>
               <a:pathLst>
-                <a:path w="28468" h="0">
+                <a:path w="31631" h="0">
                   <a:moveTo>
                     <a:pt x="0" y="0"/>
                   </a:moveTo>
                   <a:lnTo>
-                    <a:pt x="28468" y="0"/>
+                    <a:pt x="31631" y="0"/>
                   </a:lnTo>
                 </a:path>
               </a:pathLst>
@@ -3315,18 +3315,18 @@
           </p:nvSpPr>
           <p:spPr>
             <a:xfrm>
-              <a:off x="662975" y="1789859"/>
-              <a:ext cx="28468" cy="0"/>
+              <a:off x="697838" y="1598137"/>
+              <a:ext cx="31631" cy="0"/>
             </a:xfrm>
             <a:custGeom>
               <a:avLst/>
               <a:pathLst>
-                <a:path w="28468" h="0">
+                <a:path w="31631" h="0">
                   <a:moveTo>
                     <a:pt x="0" y="0"/>
                   </a:moveTo>
                   <a:lnTo>
-                    <a:pt x="28468" y="0"/>
+                    <a:pt x="31631" y="0"/>
                   </a:lnTo>
                 </a:path>
               </a:pathLst>
@@ -3355,18 +3355,18 @@
           </p:nvSpPr>
           <p:spPr>
             <a:xfrm>
-              <a:off x="662975" y="994852"/>
-              <a:ext cx="28468" cy="0"/>
+              <a:off x="697838" y="954792"/>
+              <a:ext cx="31631" cy="0"/>
             </a:xfrm>
             <a:custGeom>
               <a:avLst/>
               <a:pathLst>
-                <a:path w="28468" h="0">
+                <a:path w="31631" h="0">
                   <a:moveTo>
                     <a:pt x="0" y="0"/>
                   </a:moveTo>
                   <a:lnTo>
-                    <a:pt x="28468" y="0"/>
+                    <a:pt x="31631" y="0"/>
                   </a:lnTo>
                 </a:path>
               </a:pathLst>
@@ -3395,18 +3395,18 @@
           </p:nvSpPr>
           <p:spPr>
             <a:xfrm>
-              <a:off x="691444" y="3509570"/>
-              <a:ext cx="2734675" cy="0"/>
+              <a:off x="729470" y="2989780"/>
+              <a:ext cx="1879635" cy="0"/>
             </a:xfrm>
             <a:custGeom>
               <a:avLst/>
               <a:pathLst>
-                <a:path w="2734675" h="0">
+                <a:path w="1879635" h="0">
                   <a:moveTo>
                     <a:pt x="0" y="0"/>
                   </a:moveTo>
                   <a:lnTo>
-                    <a:pt x="2734675" y="0"/>
+                    <a:pt x="1879635" y="0"/>
                   </a:lnTo>
                 </a:path>
               </a:pathLst>
@@ -3435,15 +3435,15 @@
           </p:nvSpPr>
           <p:spPr>
             <a:xfrm>
-              <a:off x="956090" y="3509570"/>
-              <a:ext cx="0" cy="28468"/>
+              <a:off x="911370" y="2989780"/>
+              <a:ext cx="0" cy="31631"/>
             </a:xfrm>
             <a:custGeom>
               <a:avLst/>
               <a:pathLst>
-                <a:path w="0" h="28468">
+                <a:path w="0" h="31631">
                   <a:moveTo>
-                    <a:pt x="0" y="28468"/>
+                    <a:pt x="0" y="31631"/>
                   </a:moveTo>
                   <a:lnTo>
                     <a:pt x="0" y="0"/>
@@ -3475,15 +3475,15 @@
           </p:nvSpPr>
           <p:spPr>
             <a:xfrm>
-              <a:off x="1397166" y="3509570"/>
-              <a:ext cx="0" cy="28468"/>
+              <a:off x="1214537" y="2989780"/>
+              <a:ext cx="0" cy="31631"/>
             </a:xfrm>
             <a:custGeom>
               <a:avLst/>
               <a:pathLst>
-                <a:path w="0" h="28468">
+                <a:path w="0" h="31631">
                   <a:moveTo>
-                    <a:pt x="0" y="28468"/>
+                    <a:pt x="0" y="31631"/>
                   </a:moveTo>
                   <a:lnTo>
                     <a:pt x="0" y="0"/>
@@ -3515,15 +3515,15 @@
           </p:nvSpPr>
           <p:spPr>
             <a:xfrm>
-              <a:off x="1838243" y="3509570"/>
-              <a:ext cx="0" cy="28468"/>
+              <a:off x="1517704" y="2989780"/>
+              <a:ext cx="0" cy="31631"/>
             </a:xfrm>
             <a:custGeom>
               <a:avLst/>
               <a:pathLst>
-                <a:path w="0" h="28468">
+                <a:path w="0" h="31631">
                   <a:moveTo>
-                    <a:pt x="0" y="28468"/>
+                    <a:pt x="0" y="31631"/>
                   </a:moveTo>
                   <a:lnTo>
                     <a:pt x="0" y="0"/>
@@ -3555,15 +3555,15 @@
           </p:nvSpPr>
           <p:spPr>
             <a:xfrm>
-              <a:off x="2279320" y="3509570"/>
-              <a:ext cx="0" cy="28468"/>
+              <a:off x="1820871" y="2989780"/>
+              <a:ext cx="0" cy="31631"/>
             </a:xfrm>
             <a:custGeom>
               <a:avLst/>
               <a:pathLst>
-                <a:path w="0" h="28468">
+                <a:path w="0" h="31631">
                   <a:moveTo>
-                    <a:pt x="0" y="28468"/>
+                    <a:pt x="0" y="31631"/>
                   </a:moveTo>
                   <a:lnTo>
                     <a:pt x="0" y="0"/>
@@ -3595,15 +3595,15 @@
           </p:nvSpPr>
           <p:spPr>
             <a:xfrm>
-              <a:off x="2720396" y="3509570"/>
-              <a:ext cx="0" cy="28468"/>
+              <a:off x="2124038" y="2989780"/>
+              <a:ext cx="0" cy="31631"/>
             </a:xfrm>
             <a:custGeom>
               <a:avLst/>
               <a:pathLst>
-                <a:path w="0" h="28468">
+                <a:path w="0" h="31631">
                   <a:moveTo>
-                    <a:pt x="0" y="28468"/>
+                    <a:pt x="0" y="31631"/>
                   </a:moveTo>
                   <a:lnTo>
                     <a:pt x="0" y="0"/>
@@ -3635,15 +3635,15 @@
           </p:nvSpPr>
           <p:spPr>
             <a:xfrm>
-              <a:off x="3161473" y="3509570"/>
-              <a:ext cx="0" cy="28468"/>
+              <a:off x="2427205" y="2989780"/>
+              <a:ext cx="0" cy="31631"/>
             </a:xfrm>
             <a:custGeom>
               <a:avLst/>
               <a:pathLst>
-                <a:path w="0" h="28468">
+                <a:path w="0" h="31631">
                   <a:moveTo>
-                    <a:pt x="0" y="28468"/>
+                    <a:pt x="0" y="31631"/>
                   </a:moveTo>
                   <a:lnTo>
                     <a:pt x="0" y="0"/>
@@ -3675,8 +3675,8 @@
           </p:nvSpPr>
           <p:spPr>
             <a:xfrm rot="-1500000">
-              <a:off x="674968" y="3623137"/>
-              <a:ext cx="309432" cy="65379"/>
+              <a:off x="598258" y="3116132"/>
+              <a:ext cx="344637" cy="72786"/>
             </a:xfrm>
             <a:prstGeom prst="rect">
               <a:avLst/>
@@ -3696,7 +3696,7 @@
                 </a:spcAft>
               </a:pPr>
               <a:r>
-                <a:rPr sz="720" i="0" b="0">
+                <a:rPr sz="800" i="0" b="0">
                   <a:solidFill>
                     <a:srgbClr val="262626">
                       <a:alpha val="100000"/>
@@ -3718,8 +3718,8 @@
           </p:nvSpPr>
           <p:spPr>
             <a:xfrm rot="-1500000">
-              <a:off x="688194" y="3717989"/>
-              <a:ext cx="758311" cy="65379"/>
+              <a:off x="424854" y="3221785"/>
+              <a:ext cx="844631" cy="72786"/>
             </a:xfrm>
             <a:prstGeom prst="rect">
               <a:avLst/>
@@ -3739,7 +3739,7 @@
                 </a:spcAft>
               </a:pPr>
               <a:r>
-                <a:rPr sz="720" i="0" b="0">
+                <a:rPr sz="800" i="0" b="0">
                   <a:solidFill>
                     <a:srgbClr val="262626">
                       <a:alpha val="100000"/>
@@ -3761,8 +3761,8 @@
           </p:nvSpPr>
           <p:spPr>
             <a:xfrm rot="-1500000">
-              <a:off x="1302983" y="3680449"/>
-              <a:ext cx="157093" cy="65379"/>
+              <a:off x="1109473" y="3179737"/>
+              <a:ext cx="175016" cy="72786"/>
             </a:xfrm>
             <a:prstGeom prst="rect">
               <a:avLst/>
@@ -3782,7 +3782,7 @@
                 </a:spcAft>
               </a:pPr>
               <a:r>
-                <a:rPr sz="720" i="0" b="0">
+                <a:rPr sz="800" i="0" b="0">
                   <a:solidFill>
                     <a:srgbClr val="262626">
                       <a:alpha val="100000"/>
@@ -3804,8 +3804,8 @@
           </p:nvSpPr>
           <p:spPr>
             <a:xfrm rot="-1500000">
-              <a:off x="1607933" y="3611872"/>
-              <a:ext cx="256123" cy="65379"/>
+              <a:off x="1261156" y="3103592"/>
+              <a:ext cx="285292" cy="72786"/>
             </a:xfrm>
             <a:prstGeom prst="rect">
               <a:avLst/>
@@ -3825,7 +3825,7 @@
                 </a:spcAft>
               </a:pPr>
               <a:r>
-                <a:rPr sz="720" i="0" b="0">
+                <a:rPr sz="800" i="0" b="0">
                   <a:solidFill>
                     <a:srgbClr val="262626">
                       <a:alpha val="100000"/>
@@ -3847,8 +3847,8 @@
           </p:nvSpPr>
           <p:spPr>
             <a:xfrm rot="-1500000">
-              <a:off x="1628480" y="3705101"/>
-              <a:ext cx="697321" cy="65379"/>
+              <a:off x="1095858" y="3207448"/>
+              <a:ext cx="776782" cy="72786"/>
             </a:xfrm>
             <a:prstGeom prst="rect">
               <a:avLst/>
@@ -3868,7 +3868,7 @@
                 </a:spcAft>
               </a:pPr>
               <a:r>
-                <a:rPr sz="720" i="0" b="0">
+                <a:rPr sz="800" i="0" b="0">
                   <a:solidFill>
                     <a:srgbClr val="262626">
                       <a:alpha val="100000"/>
@@ -3890,8 +3890,8 @@
           </p:nvSpPr>
           <p:spPr>
             <a:xfrm rot="-1500000">
-              <a:off x="2059544" y="3708292"/>
-              <a:ext cx="288858" cy="65379"/>
+              <a:off x="1576095" y="3210710"/>
+              <a:ext cx="321594" cy="72786"/>
             </a:xfrm>
             <a:prstGeom prst="rect">
               <a:avLst/>
@@ -3911,7 +3911,7 @@
                 </a:spcAft>
               </a:pPr>
               <a:r>
-                <a:rPr sz="720" i="0" b="0">
+                <a:rPr sz="800" i="0" b="0">
                   <a:solidFill>
                     <a:srgbClr val="262626">
                       <a:alpha val="100000"/>
@@ -3933,8 +3933,8 @@
           </p:nvSpPr>
           <p:spPr>
             <a:xfrm rot="-1500000">
-              <a:off x="1779413" y="3769424"/>
-              <a:ext cx="1001725" cy="65379"/>
+              <a:off x="1076110" y="3279037"/>
+              <a:ext cx="1115568" cy="72786"/>
             </a:xfrm>
             <a:prstGeom prst="rect">
               <a:avLst/>
@@ -3954,7 +3954,7 @@
                 </a:spcAft>
               </a:pPr>
               <a:r>
-                <a:rPr sz="720" i="0" b="0">
+                <a:rPr sz="800" i="0" b="0">
                   <a:solidFill>
                     <a:srgbClr val="262626">
                       <a:alpha val="100000"/>
@@ -3976,8 +3976,8 @@
           </p:nvSpPr>
           <p:spPr>
             <a:xfrm rot="-1500000">
-              <a:off x="2318803" y="3747629"/>
-              <a:ext cx="898580" cy="65379"/>
+              <a:off x="1488484" y="3254826"/>
+              <a:ext cx="1000993" cy="72786"/>
             </a:xfrm>
             <a:prstGeom prst="rect">
               <a:avLst/>
@@ -3997,7 +3997,7 @@
                 </a:spcAft>
               </a:pPr>
               <a:r>
-                <a:rPr sz="720" i="0" b="0">
+                <a:rPr sz="800" i="0" b="0">
                   <a:solidFill>
                     <a:srgbClr val="262626">
                       <a:alpha val="100000"/>
@@ -4019,8 +4019,8 @@
           </p:nvSpPr>
           <p:spPr>
             <a:xfrm rot="-5400000">
-              <a:off x="153207" y="2041979"/>
-              <a:ext cx="482803" cy="81838"/>
+              <a:off x="130895" y="1789782"/>
+              <a:ext cx="536569" cy="90982"/>
             </a:xfrm>
             <a:prstGeom prst="rect">
               <a:avLst/>
@@ -4040,7 +4040,7 @@
                 </a:spcAft>
               </a:pPr>
               <a:r>
-                <a:rPr sz="900" i="0" b="0">
+                <a:rPr sz="1000" i="0" b="0">
                   <a:solidFill>
                     <a:srgbClr val="0D0D0D">
                       <a:alpha val="100000"/>
@@ -4062,8 +4062,8 @@
           </p:nvSpPr>
           <p:spPr>
             <a:xfrm>
-              <a:off x="691444" y="503004"/>
-              <a:ext cx="681868" cy="74432"/>
+              <a:off x="729470" y="509330"/>
+              <a:ext cx="765535" cy="83576"/>
             </a:xfrm>
             <a:prstGeom prst="rect">
               <a:avLst/>
@@ -4083,7 +4083,7 @@
                 </a:spcAft>
               </a:pPr>
               <a:r>
-                <a:rPr sz="819" i="0" b="0">
+                <a:rPr sz="919" i="0" b="0">
                   <a:solidFill>
                     <a:srgbClr val="4D4D4D">
                       <a:alpha val="100000"/>
@@ -4105,7 +4105,7 @@
           </p:nvSpPr>
           <p:spPr>
             <a:xfrm>
-              <a:off x="691444" y="328384"/>
+              <a:off x="729470" y="328384"/>
               <a:ext cx="155173" cy="90982"/>
             </a:xfrm>
             <a:prstGeom prst="rect">
@@ -4148,8 +4148,8 @@
           </p:nvSpPr>
           <p:spPr>
             <a:xfrm>
-              <a:off x="326669" y="329779"/>
-              <a:ext cx="84764" cy="109179"/>
+              <a:off x="319063" y="318395"/>
+              <a:ext cx="91805" cy="118231"/>
             </a:xfrm>
             <a:prstGeom prst="rect">
               <a:avLst/>
@@ -4169,7 +4169,7 @@
                 </a:spcAft>
               </a:pPr>
               <a:r>
-                <a:rPr sz="1200" i="0" b="1">
+                <a:rPr sz="1300" i="0" b="1">
                   <a:solidFill>
                     <a:srgbClr val="000000">
                       <a:alpha val="100000"/>
@@ -4191,8 +4191,8 @@
           </p:nvSpPr>
           <p:spPr>
             <a:xfrm>
-              <a:off x="3940894" y="656226"/>
-              <a:ext cx="2734675" cy="2853344"/>
+              <a:off x="3159072" y="680766"/>
+              <a:ext cx="1879635" cy="2309014"/>
             </a:xfrm>
             <a:prstGeom prst="rect">
               <a:avLst/>
@@ -4217,21 +4217,21 @@
           </p:nvSpPr>
           <p:spPr>
             <a:xfrm>
-              <a:off x="3940894" y="2935321"/>
-              <a:ext cx="2734675" cy="0"/>
+              <a:off x="3159072" y="2525079"/>
+              <a:ext cx="1879635" cy="0"/>
             </a:xfrm>
             <a:custGeom>
               <a:avLst/>
               <a:pathLst>
-                <a:path w="2734675" h="0">
+                <a:path w="1879635" h="0">
                   <a:moveTo>
                     <a:pt x="0" y="0"/>
                   </a:moveTo>
                   <a:lnTo>
-                    <a:pt x="2734675" y="0"/>
+                    <a:pt x="1879635" y="0"/>
                   </a:lnTo>
                   <a:lnTo>
-                    <a:pt x="2734675" y="0"/>
+                    <a:pt x="1879635" y="0"/>
                   </a:lnTo>
                 </a:path>
               </a:pathLst>
@@ -4260,21 +4260,21 @@
           </p:nvSpPr>
           <p:spPr>
             <a:xfrm>
-              <a:off x="3940894" y="2174566"/>
-              <a:ext cx="2734675" cy="0"/>
+              <a:off x="3159072" y="1909454"/>
+              <a:ext cx="1879635" cy="0"/>
             </a:xfrm>
             <a:custGeom>
               <a:avLst/>
               <a:pathLst>
-                <a:path w="2734675" h="0">
+                <a:path w="1879635" h="0">
                   <a:moveTo>
                     <a:pt x="0" y="0"/>
                   </a:moveTo>
                   <a:lnTo>
-                    <a:pt x="2734675" y="0"/>
+                    <a:pt x="1879635" y="0"/>
                   </a:lnTo>
                   <a:lnTo>
-                    <a:pt x="2734675" y="0"/>
+                    <a:pt x="1879635" y="0"/>
                   </a:lnTo>
                 </a:path>
               </a:pathLst>
@@ -4303,21 +4303,21 @@
           </p:nvSpPr>
           <p:spPr>
             <a:xfrm>
-              <a:off x="3940894" y="1413812"/>
-              <a:ext cx="2734675" cy="0"/>
+              <a:off x="3159072" y="1293828"/>
+              <a:ext cx="1879635" cy="0"/>
             </a:xfrm>
             <a:custGeom>
               <a:avLst/>
               <a:pathLst>
-                <a:path w="2734675" h="0">
+                <a:path w="1879635" h="0">
                   <a:moveTo>
                     <a:pt x="0" y="0"/>
                   </a:moveTo>
                   <a:lnTo>
-                    <a:pt x="2734675" y="0"/>
+                    <a:pt x="1879635" y="0"/>
                   </a:lnTo>
                   <a:lnTo>
-                    <a:pt x="2734675" y="0"/>
+                    <a:pt x="1879635" y="0"/>
                   </a:lnTo>
                 </a:path>
               </a:pathLst>
@@ -4346,30 +4346,30 @@
           </p:nvSpPr>
           <p:spPr>
             <a:xfrm>
-              <a:off x="4205540" y="2514070"/>
-              <a:ext cx="2205383" cy="865802"/>
+              <a:off x="3340972" y="2184191"/>
+              <a:ext cx="1515834" cy="700634"/>
             </a:xfrm>
             <a:custGeom>
               <a:avLst/>
               <a:pathLst>
-                <a:path w="2205383" h="865802">
+                <a:path w="1515834" h="700634">
                   <a:moveTo>
-                    <a:pt x="0" y="865802"/>
+                    <a:pt x="0" y="700634"/>
                   </a:moveTo>
                   <a:lnTo>
-                    <a:pt x="441076" y="519566"/>
+                    <a:pt x="303166" y="420449"/>
                   </a:lnTo>
                   <a:lnTo>
-                    <a:pt x="882153" y="508896"/>
+                    <a:pt x="606333" y="411815"/>
                   </a:lnTo>
                   <a:lnTo>
-                    <a:pt x="1323230" y="0"/>
+                    <a:pt x="909500" y="0"/>
                   </a:lnTo>
                   <a:lnTo>
-                    <a:pt x="1764306" y="30537"/>
+                    <a:pt x="1212667" y="24712"/>
                   </a:lnTo>
                   <a:lnTo>
-                    <a:pt x="2205383" y="60256"/>
+                    <a:pt x="1515834" y="48761"/>
                   </a:lnTo>
                 </a:path>
               </a:pathLst>
@@ -4398,30 +4398,30 @@
           </p:nvSpPr>
           <p:spPr>
             <a:xfrm>
-              <a:off x="4205540" y="785924"/>
-              <a:ext cx="2205383" cy="676655"/>
+              <a:off x="3340972" y="785721"/>
+              <a:ext cx="1515834" cy="547570"/>
             </a:xfrm>
             <a:custGeom>
               <a:avLst/>
               <a:pathLst>
-                <a:path w="2205383" h="676655">
+                <a:path w="1515834" h="547570">
                   <a:moveTo>
-                    <a:pt x="0" y="676655"/>
+                    <a:pt x="0" y="547570"/>
                   </a:moveTo>
                   <a:lnTo>
-                    <a:pt x="441076" y="548947"/>
+                    <a:pt x="303166" y="444225"/>
                   </a:lnTo>
                   <a:lnTo>
-                    <a:pt x="882153" y="486050"/>
+                    <a:pt x="606333" y="393327"/>
                   </a:lnTo>
                   <a:lnTo>
-                    <a:pt x="1323230" y="40947"/>
+                    <a:pt x="909500" y="33136"/>
                   </a:lnTo>
                   <a:lnTo>
-                    <a:pt x="1764306" y="0"/>
+                    <a:pt x="1212667" y="0"/>
                   </a:lnTo>
                   <a:lnTo>
-                    <a:pt x="2205383" y="50348"/>
+                    <a:pt x="1515834" y="40743"/>
                   </a:lnTo>
                 </a:path>
               </a:pathLst>
@@ -4450,30 +4450,30 @@
           </p:nvSpPr>
           <p:spPr>
             <a:xfrm>
-              <a:off x="4205540" y="1743354"/>
-              <a:ext cx="2205383" cy="25549"/>
+              <a:off x="3340972" y="1560503"/>
+              <a:ext cx="1515834" cy="20675"/>
             </a:xfrm>
             <a:custGeom>
               <a:avLst/>
               <a:pathLst>
-                <a:path w="2205383" h="25549">
+                <a:path w="1515834" h="20675">
                   <a:moveTo>
                     <a:pt x="0" y="0"/>
                   </a:moveTo>
                   <a:lnTo>
-                    <a:pt x="441076" y="5348"/>
+                    <a:pt x="303166" y="4328"/>
                   </a:lnTo>
                   <a:lnTo>
-                    <a:pt x="882153" y="25549"/>
+                    <a:pt x="606333" y="20675"/>
                   </a:lnTo>
                   <a:lnTo>
-                    <a:pt x="1323230" y="6414"/>
+                    <a:pt x="909500" y="5190"/>
                   </a:lnTo>
                   <a:lnTo>
-                    <a:pt x="1764306" y="6318"/>
+                    <a:pt x="1212667" y="5112"/>
                   </a:lnTo>
                   <a:lnTo>
-                    <a:pt x="2205383" y="8751"/>
+                    <a:pt x="1515834" y="7082"/>
                   </a:lnTo>
                 </a:path>
               </a:pathLst>
@@ -4502,8 +4502,8 @@
           </p:nvSpPr>
           <p:spPr>
             <a:xfrm>
-              <a:off x="4174757" y="3349090"/>
-              <a:ext cx="61566" cy="61566"/>
+              <a:off x="3309780" y="2853633"/>
+              <a:ext cx="62384" cy="62384"/>
             </a:xfrm>
             <a:prstGeom prst="ellipse">
               <a:avLst/>
@@ -4513,7 +4513,7 @@
                 <a:alpha val="100000"/>
               </a:srgbClr>
             </a:solidFill>
-            <a:ln w="7363" cap="rnd">
+            <a:ln w="8181" cap="rnd">
               <a:solidFill>
                 <a:srgbClr val="009E73">
                   <a:alpha val="100000"/>
@@ -4537,8 +4537,8 @@
           </p:nvSpPr>
           <p:spPr>
             <a:xfrm>
-              <a:off x="4615834" y="3002854"/>
-              <a:ext cx="61566" cy="61566"/>
+              <a:off x="3612947" y="2573448"/>
+              <a:ext cx="62384" cy="62384"/>
             </a:xfrm>
             <a:prstGeom prst="ellipse">
               <a:avLst/>
@@ -4548,7 +4548,7 @@
                 <a:alpha val="100000"/>
               </a:srgbClr>
             </a:solidFill>
-            <a:ln w="7363" cap="rnd">
+            <a:ln w="8181" cap="rnd">
               <a:solidFill>
                 <a:srgbClr val="009E73">
                   <a:alpha val="100000"/>
@@ -4572,8 +4572,8 @@
           </p:nvSpPr>
           <p:spPr>
             <a:xfrm>
-              <a:off x="5056911" y="2992184"/>
-              <a:ext cx="61566" cy="61566"/>
+              <a:off x="3916114" y="2564814"/>
+              <a:ext cx="62384" cy="62384"/>
             </a:xfrm>
             <a:prstGeom prst="ellipse">
               <a:avLst/>
@@ -4583,7 +4583,7 @@
                 <a:alpha val="100000"/>
               </a:srgbClr>
             </a:solidFill>
-            <a:ln w="7363" cap="rnd">
+            <a:ln w="8181" cap="rnd">
               <a:solidFill>
                 <a:srgbClr val="009E73">
                   <a:alpha val="100000"/>
@@ -4607,8 +4607,8 @@
           </p:nvSpPr>
           <p:spPr>
             <a:xfrm>
-              <a:off x="5497987" y="2483287"/>
-              <a:ext cx="61566" cy="61566"/>
+              <a:off x="4219281" y="2152998"/>
+              <a:ext cx="62384" cy="62384"/>
             </a:xfrm>
             <a:prstGeom prst="ellipse">
               <a:avLst/>
@@ -4618,7 +4618,7 @@
                 <a:alpha val="100000"/>
               </a:srgbClr>
             </a:solidFill>
-            <a:ln w="7363" cap="rnd">
+            <a:ln w="8181" cap="rnd">
               <a:solidFill>
                 <a:srgbClr val="009E73">
                   <a:alpha val="100000"/>
@@ -4642,8 +4642,8 @@
           </p:nvSpPr>
           <p:spPr>
             <a:xfrm>
-              <a:off x="5939064" y="2513825"/>
-              <a:ext cx="61566" cy="61566"/>
+              <a:off x="4522448" y="2177711"/>
+              <a:ext cx="62384" cy="62384"/>
             </a:xfrm>
             <a:prstGeom prst="ellipse">
               <a:avLst/>
@@ -4653,7 +4653,7 @@
                 <a:alpha val="100000"/>
               </a:srgbClr>
             </a:solidFill>
-            <a:ln w="7363" cap="rnd">
+            <a:ln w="8181" cap="rnd">
               <a:solidFill>
                 <a:srgbClr val="009E73">
                   <a:alpha val="100000"/>
@@ -4677,8 +4677,8 @@
           </p:nvSpPr>
           <p:spPr>
             <a:xfrm>
-              <a:off x="6380141" y="2543544"/>
-              <a:ext cx="61566" cy="61566"/>
+              <a:off x="4825615" y="2201760"/>
+              <a:ext cx="62384" cy="62384"/>
             </a:xfrm>
             <a:prstGeom prst="ellipse">
               <a:avLst/>
@@ -4688,7 +4688,7 @@
                 <a:alpha val="100000"/>
               </a:srgbClr>
             </a:solidFill>
-            <a:ln w="7363" cap="rnd">
+            <a:ln w="8181" cap="rnd">
               <a:solidFill>
                 <a:srgbClr val="009E73">
                   <a:alpha val="100000"/>
@@ -4712,8 +4712,8 @@
           </p:nvSpPr>
           <p:spPr>
             <a:xfrm>
-              <a:off x="4174757" y="1431797"/>
-              <a:ext cx="61566" cy="61566"/>
+              <a:off x="3309780" y="1302100"/>
+              <a:ext cx="62384" cy="62384"/>
             </a:xfrm>
             <a:prstGeom prst="ellipse">
               <a:avLst/>
@@ -4723,7 +4723,7 @@
                 <a:alpha val="100000"/>
               </a:srgbClr>
             </a:solidFill>
-            <a:ln w="7363" cap="rnd">
+            <a:ln w="8181" cap="rnd">
               <a:solidFill>
                 <a:srgbClr val="0072B2">
                   <a:alpha val="100000"/>
@@ -4747,8 +4747,8 @@
           </p:nvSpPr>
           <p:spPr>
             <a:xfrm>
-              <a:off x="4615834" y="1304088"/>
-              <a:ext cx="61566" cy="61566"/>
+              <a:off x="3612947" y="1198754"/>
+              <a:ext cx="62384" cy="62384"/>
             </a:xfrm>
             <a:prstGeom prst="ellipse">
               <a:avLst/>
@@ -4758,7 +4758,7 @@
                 <a:alpha val="100000"/>
               </a:srgbClr>
             </a:solidFill>
-            <a:ln w="7363" cap="rnd">
+            <a:ln w="8181" cap="rnd">
               <a:solidFill>
                 <a:srgbClr val="0072B2">
                   <a:alpha val="100000"/>
@@ -4782,8 +4782,8 @@
           </p:nvSpPr>
           <p:spPr>
             <a:xfrm>
-              <a:off x="5056911" y="1241191"/>
-              <a:ext cx="61566" cy="61566"/>
+              <a:off x="3916114" y="1147856"/>
+              <a:ext cx="62384" cy="62384"/>
             </a:xfrm>
             <a:prstGeom prst="ellipse">
               <a:avLst/>
@@ -4793,7 +4793,7 @@
                 <a:alpha val="100000"/>
               </a:srgbClr>
             </a:solidFill>
-            <a:ln w="7363" cap="rnd">
+            <a:ln w="8181" cap="rnd">
               <a:solidFill>
                 <a:srgbClr val="0072B2">
                   <a:alpha val="100000"/>
@@ -4817,8 +4817,8 @@
           </p:nvSpPr>
           <p:spPr>
             <a:xfrm>
-              <a:off x="5497987" y="796089"/>
-              <a:ext cx="61566" cy="61566"/>
+              <a:off x="4219281" y="787666"/>
+              <a:ext cx="62384" cy="62384"/>
             </a:xfrm>
             <a:prstGeom prst="ellipse">
               <a:avLst/>
@@ -4828,7 +4828,7 @@
                 <a:alpha val="100000"/>
               </a:srgbClr>
             </a:solidFill>
-            <a:ln w="7363" cap="rnd">
+            <a:ln w="8181" cap="rnd">
               <a:solidFill>
                 <a:srgbClr val="0072B2">
                   <a:alpha val="100000"/>
@@ -4852,8 +4852,8 @@
           </p:nvSpPr>
           <p:spPr>
             <a:xfrm>
-              <a:off x="5939064" y="755141"/>
-              <a:ext cx="61566" cy="61566"/>
+              <a:off x="4522448" y="754529"/>
+              <a:ext cx="62384" cy="62384"/>
             </a:xfrm>
             <a:prstGeom prst="ellipse">
               <a:avLst/>
@@ -4863,7 +4863,7 @@
                 <a:alpha val="100000"/>
               </a:srgbClr>
             </a:solidFill>
-            <a:ln w="7363" cap="rnd">
+            <a:ln w="8181" cap="rnd">
               <a:solidFill>
                 <a:srgbClr val="0072B2">
                   <a:alpha val="100000"/>
@@ -4887,8 +4887,8 @@
           </p:nvSpPr>
           <p:spPr>
             <a:xfrm>
-              <a:off x="6380141" y="805489"/>
-              <a:ext cx="61566" cy="61566"/>
+              <a:off x="4825615" y="795273"/>
+              <a:ext cx="62384" cy="62384"/>
             </a:xfrm>
             <a:prstGeom prst="ellipse">
               <a:avLst/>
@@ -4898,7 +4898,7 @@
                 <a:alpha val="100000"/>
               </a:srgbClr>
             </a:solidFill>
-            <a:ln w="7363" cap="rnd">
+            <a:ln w="8181" cap="rnd">
               <a:solidFill>
                 <a:srgbClr val="0072B2">
                   <a:alpha val="100000"/>
@@ -4922,8 +4922,8 @@
           </p:nvSpPr>
           <p:spPr>
             <a:xfrm>
-              <a:off x="4174757" y="1712571"/>
-              <a:ext cx="61566" cy="61566"/>
+              <a:off x="3309780" y="1529311"/>
+              <a:ext cx="62384" cy="62384"/>
             </a:xfrm>
             <a:prstGeom prst="ellipse">
               <a:avLst/>
@@ -4933,7 +4933,7 @@
                 <a:alpha val="100000"/>
               </a:srgbClr>
             </a:solidFill>
-            <a:ln w="7363" cap="rnd">
+            <a:ln w="8181" cap="rnd">
               <a:solidFill>
                 <a:srgbClr val="E69F00">
                   <a:alpha val="100000"/>
@@ -4957,8 +4957,8 @@
           </p:nvSpPr>
           <p:spPr>
             <a:xfrm>
-              <a:off x="4615834" y="1717920"/>
-              <a:ext cx="61566" cy="61566"/>
+              <a:off x="3612947" y="1533640"/>
+              <a:ext cx="62384" cy="62384"/>
             </a:xfrm>
             <a:prstGeom prst="ellipse">
               <a:avLst/>
@@ -4968,7 +4968,7 @@
                 <a:alpha val="100000"/>
               </a:srgbClr>
             </a:solidFill>
-            <a:ln w="7363" cap="rnd">
+            <a:ln w="8181" cap="rnd">
               <a:solidFill>
                 <a:srgbClr val="E69F00">
                   <a:alpha val="100000"/>
@@ -4992,8 +4992,8 @@
           </p:nvSpPr>
           <p:spPr>
             <a:xfrm>
-              <a:off x="5056911" y="1738121"/>
-              <a:ext cx="61566" cy="61566"/>
+              <a:off x="3916114" y="1549987"/>
+              <a:ext cx="62384" cy="62384"/>
             </a:xfrm>
             <a:prstGeom prst="ellipse">
               <a:avLst/>
@@ -5003,7 +5003,7 @@
                 <a:alpha val="100000"/>
               </a:srgbClr>
             </a:solidFill>
-            <a:ln w="7363" cap="rnd">
+            <a:ln w="8181" cap="rnd">
               <a:solidFill>
                 <a:srgbClr val="E69F00">
                   <a:alpha val="100000"/>
@@ -5027,8 +5027,8 @@
           </p:nvSpPr>
           <p:spPr>
             <a:xfrm>
-              <a:off x="5497987" y="1718986"/>
-              <a:ext cx="61566" cy="61566"/>
+              <a:off x="4219281" y="1534502"/>
+              <a:ext cx="62384" cy="62384"/>
             </a:xfrm>
             <a:prstGeom prst="ellipse">
               <a:avLst/>
@@ -5038,7 +5038,7 @@
                 <a:alpha val="100000"/>
               </a:srgbClr>
             </a:solidFill>
-            <a:ln w="7363" cap="rnd">
+            <a:ln w="8181" cap="rnd">
               <a:solidFill>
                 <a:srgbClr val="E69F00">
                   <a:alpha val="100000"/>
@@ -5062,8 +5062,8 @@
           </p:nvSpPr>
           <p:spPr>
             <a:xfrm>
-              <a:off x="5939064" y="1718889"/>
-              <a:ext cx="61566" cy="61566"/>
+              <a:off x="4522448" y="1534424"/>
+              <a:ext cx="62384" cy="62384"/>
             </a:xfrm>
             <a:prstGeom prst="ellipse">
               <a:avLst/>
@@ -5073,7 +5073,7 @@
                 <a:alpha val="100000"/>
               </a:srgbClr>
             </a:solidFill>
-            <a:ln w="7363" cap="rnd">
+            <a:ln w="8181" cap="rnd">
               <a:solidFill>
                 <a:srgbClr val="E69F00">
                   <a:alpha val="100000"/>
@@ -5097,8 +5097,8 @@
           </p:nvSpPr>
           <p:spPr>
             <a:xfrm>
-              <a:off x="6380141" y="1721323"/>
-              <a:ext cx="61566" cy="61566"/>
+              <a:off x="4825615" y="1536393"/>
+              <a:ext cx="62384" cy="62384"/>
             </a:xfrm>
             <a:prstGeom prst="ellipse">
               <a:avLst/>
@@ -5108,7 +5108,7 @@
                 <a:alpha val="100000"/>
               </a:srgbClr>
             </a:solidFill>
-            <a:ln w="7363" cap="rnd">
+            <a:ln w="8181" cap="rnd">
               <a:solidFill>
                 <a:srgbClr val="E69F00">
                   <a:alpha val="100000"/>
@@ -5132,15 +5132,15 @@
           </p:nvSpPr>
           <p:spPr>
             <a:xfrm>
-              <a:off x="3940894" y="656226"/>
-              <a:ext cx="0" cy="2853344"/>
+              <a:off x="3159072" y="680766"/>
+              <a:ext cx="0" cy="2309014"/>
             </a:xfrm>
             <a:custGeom>
               <a:avLst/>
               <a:pathLst>
-                <a:path w="0" h="2853344">
+                <a:path w="0" h="2309014">
                   <a:moveTo>
-                    <a:pt x="0" y="2853344"/>
+                    <a:pt x="0" y="2309014"/>
                   </a:moveTo>
                   <a:lnTo>
                     <a:pt x="0" y="0"/>
@@ -5172,8 +5172,8 @@
           </p:nvSpPr>
           <p:spPr>
             <a:xfrm>
-              <a:off x="3762824" y="2902631"/>
-              <a:ext cx="126827" cy="65379"/>
+              <a:off x="2960861" y="2488686"/>
+              <a:ext cx="141274" cy="72786"/>
             </a:xfrm>
             <a:prstGeom prst="rect">
               <a:avLst/>
@@ -5193,7 +5193,7 @@
                 </a:spcAft>
               </a:pPr>
               <a:r>
-                <a:rPr sz="720" i="0" b="0">
+                <a:rPr sz="800" i="0" b="0">
                   <a:solidFill>
                     <a:srgbClr val="262626">
                       <a:alpha val="100000"/>
@@ -5215,8 +5215,8 @@
           </p:nvSpPr>
           <p:spPr>
             <a:xfrm>
-              <a:off x="3762824" y="2141877"/>
-              <a:ext cx="126827" cy="65379"/>
+              <a:off x="2960861" y="1873061"/>
+              <a:ext cx="141274" cy="72786"/>
             </a:xfrm>
             <a:prstGeom prst="rect">
               <a:avLst/>
@@ -5236,7 +5236,7 @@
                 </a:spcAft>
               </a:pPr>
               <a:r>
-                <a:rPr sz="720" i="0" b="0">
+                <a:rPr sz="800" i="0" b="0">
                   <a:solidFill>
                     <a:srgbClr val="262626">
                       <a:alpha val="100000"/>
@@ -5258,8 +5258,8 @@
           </p:nvSpPr>
           <p:spPr>
             <a:xfrm>
-              <a:off x="3762824" y="1381123"/>
-              <a:ext cx="126827" cy="65379"/>
+              <a:off x="2960861" y="1257435"/>
+              <a:ext cx="141274" cy="72786"/>
             </a:xfrm>
             <a:prstGeom prst="rect">
               <a:avLst/>
@@ -5279,7 +5279,7 @@
                 </a:spcAft>
               </a:pPr>
               <a:r>
-                <a:rPr sz="720" i="0" b="0">
+                <a:rPr sz="800" i="0" b="0">
                   <a:solidFill>
                     <a:srgbClr val="262626">
                       <a:alpha val="100000"/>
@@ -5301,18 +5301,18 @@
           </p:nvSpPr>
           <p:spPr>
             <a:xfrm>
-              <a:off x="3912426" y="2935321"/>
-              <a:ext cx="28468" cy="0"/>
+              <a:off x="3127440" y="2525079"/>
+              <a:ext cx="31631" cy="0"/>
             </a:xfrm>
             <a:custGeom>
               <a:avLst/>
               <a:pathLst>
-                <a:path w="28468" h="0">
+                <a:path w="31631" h="0">
                   <a:moveTo>
                     <a:pt x="0" y="0"/>
                   </a:moveTo>
                   <a:lnTo>
-                    <a:pt x="28468" y="0"/>
+                    <a:pt x="31631" y="0"/>
                   </a:lnTo>
                 </a:path>
               </a:pathLst>
@@ -5341,18 +5341,18 @@
           </p:nvSpPr>
           <p:spPr>
             <a:xfrm>
-              <a:off x="3912426" y="2174566"/>
-              <a:ext cx="28468" cy="0"/>
+              <a:off x="3127440" y="1909454"/>
+              <a:ext cx="31631" cy="0"/>
             </a:xfrm>
             <a:custGeom>
               <a:avLst/>
               <a:pathLst>
-                <a:path w="28468" h="0">
+                <a:path w="31631" h="0">
                   <a:moveTo>
                     <a:pt x="0" y="0"/>
                   </a:moveTo>
                   <a:lnTo>
-                    <a:pt x="28468" y="0"/>
+                    <a:pt x="31631" y="0"/>
                   </a:lnTo>
                 </a:path>
               </a:pathLst>
@@ -5381,18 +5381,18 @@
           </p:nvSpPr>
           <p:spPr>
             <a:xfrm>
-              <a:off x="3912426" y="1413812"/>
-              <a:ext cx="28468" cy="0"/>
+              <a:off x="3127440" y="1293828"/>
+              <a:ext cx="31631" cy="0"/>
             </a:xfrm>
             <a:custGeom>
               <a:avLst/>
               <a:pathLst>
-                <a:path w="28468" h="0">
+                <a:path w="31631" h="0">
                   <a:moveTo>
                     <a:pt x="0" y="0"/>
                   </a:moveTo>
                   <a:lnTo>
-                    <a:pt x="28468" y="0"/>
+                    <a:pt x="31631" y="0"/>
                   </a:lnTo>
                 </a:path>
               </a:pathLst>
@@ -5421,18 +5421,18 @@
           </p:nvSpPr>
           <p:spPr>
             <a:xfrm>
-              <a:off x="3940894" y="3509570"/>
-              <a:ext cx="2734675" cy="0"/>
+              <a:off x="3159072" y="2989780"/>
+              <a:ext cx="1879635" cy="0"/>
             </a:xfrm>
             <a:custGeom>
               <a:avLst/>
               <a:pathLst>
-                <a:path w="2734675" h="0">
+                <a:path w="1879635" h="0">
                   <a:moveTo>
                     <a:pt x="0" y="0"/>
                   </a:moveTo>
                   <a:lnTo>
-                    <a:pt x="2734675" y="0"/>
+                    <a:pt x="1879635" y="0"/>
                   </a:lnTo>
                 </a:path>
               </a:pathLst>
@@ -5461,15 +5461,15 @@
           </p:nvSpPr>
           <p:spPr>
             <a:xfrm>
-              <a:off x="4205540" y="3509570"/>
-              <a:ext cx="0" cy="28468"/>
+              <a:off x="3340972" y="2989780"/>
+              <a:ext cx="0" cy="31631"/>
             </a:xfrm>
             <a:custGeom>
               <a:avLst/>
               <a:pathLst>
-                <a:path w="0" h="28468">
+                <a:path w="0" h="31631">
                   <a:moveTo>
-                    <a:pt x="0" y="28468"/>
+                    <a:pt x="0" y="31631"/>
                   </a:moveTo>
                   <a:lnTo>
                     <a:pt x="0" y="0"/>
@@ -5501,15 +5501,15 @@
           </p:nvSpPr>
           <p:spPr>
             <a:xfrm>
-              <a:off x="4646617" y="3509570"/>
-              <a:ext cx="0" cy="28468"/>
+              <a:off x="3644139" y="2989780"/>
+              <a:ext cx="0" cy="31631"/>
             </a:xfrm>
             <a:custGeom>
               <a:avLst/>
               <a:pathLst>
-                <a:path w="0" h="28468">
+                <a:path w="0" h="31631">
                   <a:moveTo>
-                    <a:pt x="0" y="28468"/>
+                    <a:pt x="0" y="31631"/>
                   </a:moveTo>
                   <a:lnTo>
                     <a:pt x="0" y="0"/>
@@ -5541,15 +5541,15 @@
           </p:nvSpPr>
           <p:spPr>
             <a:xfrm>
-              <a:off x="5087694" y="3509570"/>
-              <a:ext cx="0" cy="28468"/>
+              <a:off x="3947306" y="2989780"/>
+              <a:ext cx="0" cy="31631"/>
             </a:xfrm>
             <a:custGeom>
               <a:avLst/>
               <a:pathLst>
-                <a:path w="0" h="28468">
+                <a:path w="0" h="31631">
                   <a:moveTo>
-                    <a:pt x="0" y="28468"/>
+                    <a:pt x="0" y="31631"/>
                   </a:moveTo>
                   <a:lnTo>
                     <a:pt x="0" y="0"/>
@@ -5581,15 +5581,15 @@
           </p:nvSpPr>
           <p:spPr>
             <a:xfrm>
-              <a:off x="5528770" y="3509570"/>
-              <a:ext cx="0" cy="28468"/>
+              <a:off x="4250473" y="2989780"/>
+              <a:ext cx="0" cy="31631"/>
             </a:xfrm>
             <a:custGeom>
               <a:avLst/>
               <a:pathLst>
-                <a:path w="0" h="28468">
+                <a:path w="0" h="31631">
                   <a:moveTo>
-                    <a:pt x="0" y="28468"/>
+                    <a:pt x="0" y="31631"/>
                   </a:moveTo>
                   <a:lnTo>
                     <a:pt x="0" y="0"/>
@@ -5621,15 +5621,15 @@
           </p:nvSpPr>
           <p:spPr>
             <a:xfrm>
-              <a:off x="5969847" y="3509570"/>
-              <a:ext cx="0" cy="28468"/>
+              <a:off x="4553640" y="2989780"/>
+              <a:ext cx="0" cy="31631"/>
             </a:xfrm>
             <a:custGeom>
               <a:avLst/>
               <a:pathLst>
-                <a:path w="0" h="28468">
+                <a:path w="0" h="31631">
                   <a:moveTo>
-                    <a:pt x="0" y="28468"/>
+                    <a:pt x="0" y="31631"/>
                   </a:moveTo>
                   <a:lnTo>
                     <a:pt x="0" y="0"/>
@@ -5661,15 +5661,15 @@
           </p:nvSpPr>
           <p:spPr>
             <a:xfrm>
-              <a:off x="6410924" y="3509570"/>
-              <a:ext cx="0" cy="28468"/>
+              <a:off x="4856807" y="2989780"/>
+              <a:ext cx="0" cy="31631"/>
             </a:xfrm>
             <a:custGeom>
               <a:avLst/>
               <a:pathLst>
-                <a:path w="0" h="28468">
+                <a:path w="0" h="31631">
                   <a:moveTo>
-                    <a:pt x="0" y="28468"/>
+                    <a:pt x="0" y="31631"/>
                   </a:moveTo>
                   <a:lnTo>
                     <a:pt x="0" y="0"/>
@@ -5701,8 +5701,8 @@
           </p:nvSpPr>
           <p:spPr>
             <a:xfrm rot="-1500000">
-              <a:off x="3924419" y="3623137"/>
-              <a:ext cx="309432" cy="65379"/>
+              <a:off x="3027860" y="3116132"/>
+              <a:ext cx="344637" cy="72786"/>
             </a:xfrm>
             <a:prstGeom prst="rect">
               <a:avLst/>
@@ -5722,7 +5722,7 @@
                 </a:spcAft>
               </a:pPr>
               <a:r>
-                <a:rPr sz="720" i="0" b="0">
+                <a:rPr sz="800" i="0" b="0">
                   <a:solidFill>
                     <a:srgbClr val="262626">
                       <a:alpha val="100000"/>
@@ -5744,8 +5744,8 @@
           </p:nvSpPr>
           <p:spPr>
             <a:xfrm rot="-1500000">
-              <a:off x="3937644" y="3717989"/>
-              <a:ext cx="758311" cy="65379"/>
+              <a:off x="2854456" y="3221785"/>
+              <a:ext cx="844631" cy="72786"/>
             </a:xfrm>
             <a:prstGeom prst="rect">
               <a:avLst/>
@@ -5765,7 +5765,7 @@
                 </a:spcAft>
               </a:pPr>
               <a:r>
-                <a:rPr sz="720" i="0" b="0">
+                <a:rPr sz="800" i="0" b="0">
                   <a:solidFill>
                     <a:srgbClr val="262626">
                       <a:alpha val="100000"/>
@@ -5787,8 +5787,8 @@
           </p:nvSpPr>
           <p:spPr>
             <a:xfrm rot="-1500000">
-              <a:off x="4552433" y="3680449"/>
-              <a:ext cx="157093" cy="65379"/>
+              <a:off x="3539075" y="3179737"/>
+              <a:ext cx="175016" cy="72786"/>
             </a:xfrm>
             <a:prstGeom prst="rect">
               <a:avLst/>
@@ -5808,7 +5808,7 @@
                 </a:spcAft>
               </a:pPr>
               <a:r>
-                <a:rPr sz="720" i="0" b="0">
+                <a:rPr sz="800" i="0" b="0">
                   <a:solidFill>
                     <a:srgbClr val="262626">
                       <a:alpha val="100000"/>
@@ -5830,8 +5830,8 @@
           </p:nvSpPr>
           <p:spPr>
             <a:xfrm rot="-1500000">
-              <a:off x="4857384" y="3611872"/>
-              <a:ext cx="256123" cy="65379"/>
+              <a:off x="3690758" y="3103592"/>
+              <a:ext cx="285292" cy="72786"/>
             </a:xfrm>
             <a:prstGeom prst="rect">
               <a:avLst/>
@@ -5851,7 +5851,7 @@
                 </a:spcAft>
               </a:pPr>
               <a:r>
-                <a:rPr sz="720" i="0" b="0">
+                <a:rPr sz="800" i="0" b="0">
                   <a:solidFill>
                     <a:srgbClr val="262626">
                       <a:alpha val="100000"/>
@@ -5873,8 +5873,8 @@
           </p:nvSpPr>
           <p:spPr>
             <a:xfrm rot="-1500000">
-              <a:off x="4877931" y="3705101"/>
-              <a:ext cx="697321" cy="65379"/>
+              <a:off x="3525460" y="3207448"/>
+              <a:ext cx="776782" cy="72786"/>
             </a:xfrm>
             <a:prstGeom prst="rect">
               <a:avLst/>
@@ -5894,7 +5894,7 @@
                 </a:spcAft>
               </a:pPr>
               <a:r>
-                <a:rPr sz="720" i="0" b="0">
+                <a:rPr sz="800" i="0" b="0">
                   <a:solidFill>
                     <a:srgbClr val="262626">
                       <a:alpha val="100000"/>
@@ -5916,8 +5916,8 @@
           </p:nvSpPr>
           <p:spPr>
             <a:xfrm rot="-1500000">
-              <a:off x="5308994" y="3708292"/>
-              <a:ext cx="288858" cy="65379"/>
+              <a:off x="4005697" y="3210710"/>
+              <a:ext cx="321594" cy="72786"/>
             </a:xfrm>
             <a:prstGeom prst="rect">
               <a:avLst/>
@@ -5937,7 +5937,7 @@
                 </a:spcAft>
               </a:pPr>
               <a:r>
-                <a:rPr sz="720" i="0" b="0">
+                <a:rPr sz="800" i="0" b="0">
                   <a:solidFill>
                     <a:srgbClr val="262626">
                       <a:alpha val="100000"/>
@@ -5959,8 +5959,8 @@
           </p:nvSpPr>
           <p:spPr>
             <a:xfrm rot="-1500000">
-              <a:off x="5028864" y="3769424"/>
-              <a:ext cx="1001725" cy="65379"/>
+              <a:off x="3505712" y="3279037"/>
+              <a:ext cx="1115568" cy="72786"/>
             </a:xfrm>
             <a:prstGeom prst="rect">
               <a:avLst/>
@@ -5980,7 +5980,7 @@
                 </a:spcAft>
               </a:pPr>
               <a:r>
-                <a:rPr sz="720" i="0" b="0">
+                <a:rPr sz="800" i="0" b="0">
                   <a:solidFill>
                     <a:srgbClr val="262626">
                       <a:alpha val="100000"/>
@@ -6002,8 +6002,8 @@
           </p:nvSpPr>
           <p:spPr>
             <a:xfrm rot="-1500000">
-              <a:off x="5568253" y="3747629"/>
-              <a:ext cx="898580" cy="65379"/>
+              <a:off x="3918086" y="3254826"/>
+              <a:ext cx="1000993" cy="72786"/>
             </a:xfrm>
             <a:prstGeom prst="rect">
               <a:avLst/>
@@ -6023,7 +6023,7 @@
                 </a:spcAft>
               </a:pPr>
               <a:r>
-                <a:rPr sz="720" i="0" b="0">
+                <a:rPr sz="800" i="0" b="0">
                   <a:solidFill>
                     <a:srgbClr val="262626">
                       <a:alpha val="100000"/>
@@ -6045,8 +6045,8 @@
           </p:nvSpPr>
           <p:spPr>
             <a:xfrm rot="-5400000">
-              <a:off x="2789689" y="2041979"/>
-              <a:ext cx="1759579" cy="81838"/>
+              <a:off x="1878675" y="1789782"/>
+              <a:ext cx="1956724" cy="90982"/>
             </a:xfrm>
             <a:prstGeom prst="rect">
               <a:avLst/>
@@ -6066,7 +6066,7 @@
                 </a:spcAft>
               </a:pPr>
               <a:r>
-                <a:rPr sz="900" i="0" b="0">
+                <a:rPr sz="1000" i="0" b="0">
                   <a:solidFill>
                     <a:srgbClr val="0D0D0D">
                       <a:alpha val="100000"/>
@@ -6088,8 +6088,8 @@
           </p:nvSpPr>
           <p:spPr>
             <a:xfrm>
-              <a:off x="4191507" y="1855153"/>
-              <a:ext cx="1030192" cy="455491"/>
+              <a:off x="3114195" y="1601201"/>
+              <a:ext cx="1142348" cy="468144"/>
             </a:xfrm>
             <a:prstGeom prst="rect">
               <a:avLst/>
@@ -6114,7 +6114,7 @@
           </p:nvSpPr>
           <p:spPr>
             <a:xfrm>
-              <a:off x="4248444" y="1912089"/>
+              <a:off x="3177458" y="1664464"/>
               <a:ext cx="113872" cy="113872"/>
             </a:xfrm>
             <a:prstGeom prst="rect">
@@ -6140,7 +6140,7 @@
           </p:nvSpPr>
           <p:spPr>
             <a:xfrm>
-              <a:off x="4259831" y="1969025"/>
+              <a:off x="3188845" y="1721400"/>
               <a:ext cx="91098" cy="0"/>
             </a:xfrm>
             <a:custGeom>
@@ -6180,8 +6180,8 @@
           </p:nvSpPr>
           <p:spPr>
             <a:xfrm>
-              <a:off x="4274597" y="1938242"/>
-              <a:ext cx="61566" cy="61566"/>
+              <a:off x="3203202" y="1690208"/>
+              <a:ext cx="62384" cy="62384"/>
             </a:xfrm>
             <a:prstGeom prst="ellipse">
               <a:avLst/>
@@ -6191,7 +6191,7 @@
                 <a:alpha val="100000"/>
               </a:srgbClr>
             </a:solidFill>
-            <a:ln w="7363" cap="rnd">
+            <a:ln w="8181" cap="rnd">
               <a:solidFill>
                 <a:srgbClr val="009E73">
                   <a:alpha val="100000"/>
@@ -6215,7 +6215,7 @@
           </p:nvSpPr>
           <p:spPr>
             <a:xfrm>
-              <a:off x="4248444" y="2025962"/>
+              <a:off x="3177458" y="1778337"/>
               <a:ext cx="113872" cy="113872"/>
             </a:xfrm>
             <a:prstGeom prst="rect">
@@ -6241,7 +6241,7 @@
           </p:nvSpPr>
           <p:spPr>
             <a:xfrm>
-              <a:off x="4259831" y="2082898"/>
+              <a:off x="3188845" y="1835273"/>
               <a:ext cx="91098" cy="0"/>
             </a:xfrm>
             <a:custGeom>
@@ -6281,8 +6281,8 @@
           </p:nvSpPr>
           <p:spPr>
             <a:xfrm>
-              <a:off x="4274597" y="2052115"/>
-              <a:ext cx="61566" cy="61566"/>
+              <a:off x="3203202" y="1804081"/>
+              <a:ext cx="62384" cy="62384"/>
             </a:xfrm>
             <a:prstGeom prst="ellipse">
               <a:avLst/>
@@ -6292,7 +6292,7 @@
                 <a:alpha val="100000"/>
               </a:srgbClr>
             </a:solidFill>
-            <a:ln w="7363" cap="rnd">
+            <a:ln w="8181" cap="rnd">
               <a:solidFill>
                 <a:srgbClr val="0072B2">
                   <a:alpha val="100000"/>
@@ -6316,7 +6316,7 @@
           </p:nvSpPr>
           <p:spPr>
             <a:xfrm>
-              <a:off x="4248444" y="2139835"/>
+              <a:off x="3177458" y="1892210"/>
               <a:ext cx="113872" cy="113872"/>
             </a:xfrm>
             <a:prstGeom prst="rect">
@@ -6342,7 +6342,7 @@
           </p:nvSpPr>
           <p:spPr>
             <a:xfrm>
-              <a:off x="4259831" y="2196771"/>
+              <a:off x="3188845" y="1949146"/>
               <a:ext cx="91098" cy="0"/>
             </a:xfrm>
             <a:custGeom>
@@ -6382,8 +6382,8 @@
           </p:nvSpPr>
           <p:spPr>
             <a:xfrm>
-              <a:off x="4274597" y="2165988"/>
-              <a:ext cx="61566" cy="61566"/>
+              <a:off x="3203202" y="1917954"/>
+              <a:ext cx="62384" cy="62384"/>
             </a:xfrm>
             <a:prstGeom prst="ellipse">
               <a:avLst/>
@@ -6393,7 +6393,7 @@
                 <a:alpha val="100000"/>
               </a:srgbClr>
             </a:solidFill>
-            <a:ln w="7363" cap="rnd">
+            <a:ln w="8181" cap="rnd">
               <a:solidFill>
                 <a:srgbClr val="E69F00">
                   <a:alpha val="100000"/>
@@ -6417,8 +6417,8 @@
           </p:nvSpPr>
           <p:spPr>
             <a:xfrm>
-              <a:off x="4419253" y="1932632"/>
-              <a:ext cx="666506" cy="72786"/>
+              <a:off x="3354594" y="1680481"/>
+              <a:ext cx="749716" cy="81838"/>
             </a:xfrm>
             <a:prstGeom prst="rect">
               <a:avLst/>
@@ -6438,7 +6438,7 @@
                 </a:spcAft>
               </a:pPr>
               <a:r>
-                <a:rPr sz="800" i="0" b="0">
+                <a:rPr sz="900" i="0" b="0">
                   <a:solidFill>
                     <a:srgbClr val="000000">
                       <a:alpha val="100000"/>
@@ -6460,8 +6460,8 @@
           </p:nvSpPr>
           <p:spPr>
             <a:xfrm>
-              <a:off x="4419253" y="2046505"/>
-              <a:ext cx="745510" cy="72786"/>
+              <a:off x="3354594" y="1794354"/>
+              <a:ext cx="838687" cy="81838"/>
             </a:xfrm>
             <a:prstGeom prst="rect">
               <a:avLst/>
@@ -6481,7 +6481,7 @@
                 </a:spcAft>
               </a:pPr>
               <a:r>
-                <a:rPr sz="800" i="0" b="0">
+                <a:rPr sz="900" i="0" b="0">
                   <a:solidFill>
                     <a:srgbClr val="000000">
                       <a:alpha val="100000"/>
@@ -6503,8 +6503,8 @@
           </p:nvSpPr>
           <p:spPr>
             <a:xfrm>
-              <a:off x="4419253" y="2160378"/>
-              <a:ext cx="626729" cy="72786"/>
+              <a:off x="3354594" y="1908227"/>
+              <a:ext cx="705093" cy="81838"/>
             </a:xfrm>
             <a:prstGeom prst="rect">
               <a:avLst/>
@@ -6524,7 +6524,7 @@
                 </a:spcAft>
               </a:pPr>
               <a:r>
-                <a:rPr sz="800" i="0" b="0">
+                <a:rPr sz="900" i="0" b="0">
                   <a:solidFill>
                     <a:srgbClr val="000000">
                       <a:alpha val="100000"/>
@@ -6546,8 +6546,8 @@
           </p:nvSpPr>
           <p:spPr>
             <a:xfrm>
-              <a:off x="3940894" y="503004"/>
-              <a:ext cx="1733610" cy="74432"/>
+              <a:off x="3159072" y="509330"/>
+              <a:ext cx="1945751" cy="83576"/>
             </a:xfrm>
             <a:prstGeom prst="rect">
               <a:avLst/>
@@ -6567,7 +6567,7 @@
                 </a:spcAft>
               </a:pPr>
               <a:r>
-                <a:rPr sz="819" i="0" b="0">
+                <a:rPr sz="919" i="0" b="0">
                   <a:solidFill>
                     <a:srgbClr val="4D4D4D">
                       <a:alpha val="100000"/>
@@ -6589,7 +6589,7 @@
           </p:nvSpPr>
           <p:spPr>
             <a:xfrm>
-              <a:off x="3940894" y="328384"/>
+              <a:off x="3159072" y="328384"/>
               <a:ext cx="1136416" cy="90982"/>
             </a:xfrm>
             <a:prstGeom prst="rect">
@@ -6632,8 +6632,8 @@
           </p:nvSpPr>
           <p:spPr>
             <a:xfrm>
-              <a:off x="3597252" y="329779"/>
-              <a:ext cx="93085" cy="109179"/>
+              <a:off x="2772253" y="318395"/>
+              <a:ext cx="100858" cy="118231"/>
             </a:xfrm>
             <a:prstGeom prst="rect">
               <a:avLst/>
@@ -6653,7 +6653,7 @@
                 </a:spcAft>
               </a:pPr>
               <a:r>
-                <a:rPr sz="1200" i="0" b="1">
+                <a:rPr sz="1300" i="0" b="1">
                   <a:solidFill>
                     <a:srgbClr val="000000">
                       <a:alpha val="100000"/>
@@ -6675,8 +6675,8 @@
           </p:nvSpPr>
           <p:spPr>
             <a:xfrm>
-              <a:off x="7190345" y="656226"/>
-              <a:ext cx="2734675" cy="2853344"/>
+              <a:off x="5588674" y="680766"/>
+              <a:ext cx="1879635" cy="2309014"/>
             </a:xfrm>
             <a:prstGeom prst="rect">
               <a:avLst/>
@@ -6701,21 +6701,21 @@
           </p:nvSpPr>
           <p:spPr>
             <a:xfrm>
-              <a:off x="7190345" y="3379873"/>
-              <a:ext cx="2734675" cy="0"/>
+              <a:off x="5588674" y="2884825"/>
+              <a:ext cx="1879635" cy="0"/>
             </a:xfrm>
             <a:custGeom>
               <a:avLst/>
               <a:pathLst>
-                <a:path w="2734675" h="0">
+                <a:path w="1879635" h="0">
                   <a:moveTo>
                     <a:pt x="0" y="0"/>
                   </a:moveTo>
                   <a:lnTo>
-                    <a:pt x="2734675" y="0"/>
+                    <a:pt x="1879635" y="0"/>
                   </a:lnTo>
                   <a:lnTo>
-                    <a:pt x="2734675" y="0"/>
+                    <a:pt x="1879635" y="0"/>
                   </a:lnTo>
                 </a:path>
               </a:pathLst>
@@ -6744,21 +6744,21 @@
           </p:nvSpPr>
           <p:spPr>
             <a:xfrm>
-              <a:off x="7190345" y="2656519"/>
-              <a:ext cx="2734675" cy="0"/>
+              <a:off x="5588674" y="2299464"/>
+              <a:ext cx="1879635" cy="0"/>
             </a:xfrm>
             <a:custGeom>
               <a:avLst/>
               <a:pathLst>
-                <a:path w="2734675" h="0">
+                <a:path w="1879635" h="0">
                   <a:moveTo>
                     <a:pt x="0" y="0"/>
                   </a:moveTo>
                   <a:lnTo>
-                    <a:pt x="2734675" y="0"/>
+                    <a:pt x="1879635" y="0"/>
                   </a:lnTo>
                   <a:lnTo>
-                    <a:pt x="2734675" y="0"/>
+                    <a:pt x="1879635" y="0"/>
                   </a:lnTo>
                 </a:path>
               </a:pathLst>
@@ -6787,21 +6787,21 @@
           </p:nvSpPr>
           <p:spPr>
             <a:xfrm>
-              <a:off x="7190345" y="1933164"/>
-              <a:ext cx="2734675" cy="0"/>
+              <a:off x="5588674" y="1714104"/>
+              <a:ext cx="1879635" cy="0"/>
             </a:xfrm>
             <a:custGeom>
               <a:avLst/>
               <a:pathLst>
-                <a:path w="2734675" h="0">
+                <a:path w="1879635" h="0">
                   <a:moveTo>
                     <a:pt x="0" y="0"/>
                   </a:moveTo>
                   <a:lnTo>
-                    <a:pt x="2734675" y="0"/>
+                    <a:pt x="1879635" y="0"/>
                   </a:lnTo>
                   <a:lnTo>
-                    <a:pt x="2734675" y="0"/>
+                    <a:pt x="1879635" y="0"/>
                   </a:lnTo>
                 </a:path>
               </a:pathLst>
@@ -6830,21 +6830,21 @@
           </p:nvSpPr>
           <p:spPr>
             <a:xfrm>
-              <a:off x="7190345" y="1209810"/>
-              <a:ext cx="2734675" cy="0"/>
+              <a:off x="5588674" y="1128743"/>
+              <a:ext cx="1879635" cy="0"/>
             </a:xfrm>
             <a:custGeom>
               <a:avLst/>
               <a:pathLst>
-                <a:path w="2734675" h="0">
+                <a:path w="1879635" h="0">
                   <a:moveTo>
                     <a:pt x="0" y="0"/>
                   </a:moveTo>
                   <a:lnTo>
-                    <a:pt x="2734675" y="0"/>
+                    <a:pt x="1879635" y="0"/>
                   </a:lnTo>
                   <a:lnTo>
-                    <a:pt x="2734675" y="0"/>
+                    <a:pt x="1879635" y="0"/>
                   </a:lnTo>
                 </a:path>
               </a:pathLst>
@@ -6873,8 +6873,8 @@
           </p:nvSpPr>
           <p:spPr>
             <a:xfrm>
-              <a:off x="7311641" y="2817103"/>
-              <a:ext cx="286699" cy="562769"/>
+              <a:off x="5672045" y="2429414"/>
+              <a:ext cx="197058" cy="455410"/>
             </a:xfrm>
             <a:prstGeom prst="rect">
               <a:avLst/>
@@ -6899,8 +6899,8 @@
           </p:nvSpPr>
           <p:spPr>
             <a:xfrm>
-              <a:off x="7752718" y="2190678"/>
-              <a:ext cx="286699" cy="539622"/>
+              <a:off x="5975212" y="1922492"/>
+              <a:ext cx="197058" cy="436679"/>
             </a:xfrm>
             <a:prstGeom prst="rect">
               <a:avLst/>
@@ -6925,8 +6925,8 @@
           </p:nvSpPr>
           <p:spPr>
             <a:xfrm>
-              <a:off x="7752718" y="2730301"/>
-              <a:ext cx="286699" cy="649572"/>
+              <a:off x="5975212" y="2359171"/>
+              <a:ext cx="197058" cy="525653"/>
             </a:xfrm>
             <a:prstGeom prst="rect">
               <a:avLst/>
@@ -6951,8 +6951,8 @@
           </p:nvSpPr>
           <p:spPr>
             <a:xfrm>
-              <a:off x="8193795" y="1656843"/>
-              <a:ext cx="286699" cy="545409"/>
+              <a:off x="6278379" y="1490496"/>
+              <a:ext cx="197058" cy="441362"/>
             </a:xfrm>
             <a:prstGeom prst="rect">
               <a:avLst/>
@@ -6977,8 +6977,8 @@
           </p:nvSpPr>
           <p:spPr>
             <a:xfrm>
-              <a:off x="8193795" y="2202252"/>
-              <a:ext cx="286699" cy="606171"/>
+              <a:off x="6278379" y="1931858"/>
+              <a:ext cx="197058" cy="490532"/>
             </a:xfrm>
             <a:prstGeom prst="rect">
               <a:avLst/>
@@ -7003,8 +7003,8 @@
           </p:nvSpPr>
           <p:spPr>
             <a:xfrm>
-              <a:off x="8193795" y="2808423"/>
-              <a:ext cx="286699" cy="571450"/>
+              <a:off x="6278379" y="2422390"/>
+              <a:ext cx="197058" cy="462435"/>
             </a:xfrm>
             <a:prstGeom prst="rect">
               <a:avLst/>
@@ -7029,8 +7029,8 @@
           </p:nvSpPr>
           <p:spPr>
             <a:xfrm>
-              <a:off x="8634871" y="1159175"/>
-              <a:ext cx="286699" cy="585917"/>
+              <a:off x="6581546" y="1087768"/>
+              <a:ext cx="197058" cy="474142"/>
             </a:xfrm>
             <a:prstGeom prst="rect">
               <a:avLst/>
@@ -7055,8 +7055,8 @@
           </p:nvSpPr>
           <p:spPr>
             <a:xfrm>
-              <a:off x="8634871" y="1745092"/>
-              <a:ext cx="286699" cy="471627"/>
+              <a:off x="6581546" y="1561910"/>
+              <a:ext cx="197058" cy="381655"/>
             </a:xfrm>
             <a:prstGeom prst="rect">
               <a:avLst/>
@@ -7081,8 +7081,8 @@
           </p:nvSpPr>
           <p:spPr>
             <a:xfrm>
-              <a:off x="8634871" y="2216719"/>
-              <a:ext cx="286699" cy="1163153"/>
+              <a:off x="6581546" y="1943565"/>
+              <a:ext cx="197058" cy="941260"/>
             </a:xfrm>
             <a:prstGeom prst="rect">
               <a:avLst/>
@@ -7107,8 +7107,8 @@
           </p:nvSpPr>
           <p:spPr>
             <a:xfrm>
-              <a:off x="9075948" y="826432"/>
-              <a:ext cx="286699" cy="543962"/>
+              <a:off x="6884713" y="818502"/>
+              <a:ext cx="197058" cy="440191"/>
             </a:xfrm>
             <a:prstGeom prst="rect">
               <a:avLst/>
@@ -7133,8 +7133,8 @@
           </p:nvSpPr>
           <p:spPr>
             <a:xfrm>
-              <a:off x="9075948" y="1370394"/>
-              <a:ext cx="286699" cy="441246"/>
+              <a:off x="6884713" y="1258693"/>
+              <a:ext cx="197058" cy="357070"/>
             </a:xfrm>
             <a:prstGeom prst="rect">
               <a:avLst/>
@@ -7159,8 +7159,8 @@
           </p:nvSpPr>
           <p:spPr>
             <a:xfrm>
-              <a:off x="9075948" y="1811641"/>
-              <a:ext cx="286699" cy="1171834"/>
+              <a:off x="6884713" y="1615763"/>
+              <a:ext cx="197058" cy="948284"/>
             </a:xfrm>
             <a:prstGeom prst="rect">
               <a:avLst/>
@@ -7185,8 +7185,8 @@
           </p:nvSpPr>
           <p:spPr>
             <a:xfrm>
-              <a:off x="9075948" y="2983475"/>
-              <a:ext cx="286699" cy="396398"/>
+              <a:off x="6884713" y="2564047"/>
+              <a:ext cx="197058" cy="320777"/>
             </a:xfrm>
             <a:prstGeom prst="rect">
               <a:avLst/>
@@ -7211,8 +7211,8 @@
           </p:nvSpPr>
           <p:spPr>
             <a:xfrm>
-              <a:off x="9517025" y="785924"/>
-              <a:ext cx="286699" cy="581576"/>
+              <a:off x="7187879" y="785721"/>
+              <a:ext cx="197058" cy="470630"/>
             </a:xfrm>
             <a:prstGeom prst="rect">
               <a:avLst/>
@@ -7237,8 +7237,8 @@
           </p:nvSpPr>
           <p:spPr>
             <a:xfrm>
-              <a:off x="9517025" y="1367501"/>
-              <a:ext cx="286699" cy="473073"/>
+              <a:off x="7187879" y="1256351"/>
+              <a:ext cx="197058" cy="382825"/>
             </a:xfrm>
             <a:prstGeom prst="rect">
               <a:avLst/>
@@ -7263,8 +7263,8 @@
           </p:nvSpPr>
           <p:spPr>
             <a:xfrm>
-              <a:off x="9517025" y="1840575"/>
-              <a:ext cx="286699" cy="1102392"/>
+              <a:off x="7187879" y="1639177"/>
+              <a:ext cx="197058" cy="892089"/>
             </a:xfrm>
             <a:prstGeom prst="rect">
               <a:avLst/>
@@ -7289,8 +7289,8 @@
           </p:nvSpPr>
           <p:spPr>
             <a:xfrm>
-              <a:off x="9517025" y="2942967"/>
-              <a:ext cx="286699" cy="436906"/>
+              <a:off x="7187879" y="2531267"/>
+              <a:ext cx="197058" cy="353557"/>
             </a:xfrm>
             <a:prstGeom prst="rect">
               <a:avLst/>
@@ -7315,15 +7315,15 @@
           </p:nvSpPr>
           <p:spPr>
             <a:xfrm>
-              <a:off x="7190345" y="656226"/>
-              <a:ext cx="0" cy="2853344"/>
+              <a:off x="5588674" y="680766"/>
+              <a:ext cx="0" cy="2309014"/>
             </a:xfrm>
             <a:custGeom>
               <a:avLst/>
               <a:pathLst>
-                <a:path w="0" h="2853344">
+                <a:path w="0" h="2309014">
                   <a:moveTo>
-                    <a:pt x="0" y="2853344"/>
+                    <a:pt x="0" y="2309014"/>
                   </a:moveTo>
                   <a:lnTo>
                     <a:pt x="0" y="0"/>
@@ -7355,8 +7355,8 @@
           </p:nvSpPr>
           <p:spPr>
             <a:xfrm>
-              <a:off x="7012275" y="3347183"/>
-              <a:ext cx="126827" cy="65379"/>
+              <a:off x="5390462" y="2848432"/>
+              <a:ext cx="141274" cy="72786"/>
             </a:xfrm>
             <a:prstGeom prst="rect">
               <a:avLst/>
@@ -7376,7 +7376,7 @@
                 </a:spcAft>
               </a:pPr>
               <a:r>
-                <a:rPr sz="720" i="0" b="0">
+                <a:rPr sz="800" i="0" b="0">
                   <a:solidFill>
                     <a:srgbClr val="262626">
                       <a:alpha val="100000"/>
@@ -7398,8 +7398,8 @@
           </p:nvSpPr>
           <p:spPr>
             <a:xfrm>
-              <a:off x="7012275" y="2623829"/>
-              <a:ext cx="126827" cy="65379"/>
+              <a:off x="5390462" y="2263071"/>
+              <a:ext cx="141274" cy="72786"/>
             </a:xfrm>
             <a:prstGeom prst="rect">
               <a:avLst/>
@@ -7419,7 +7419,7 @@
                 </a:spcAft>
               </a:pPr>
               <a:r>
-                <a:rPr sz="720" i="0" b="0">
+                <a:rPr sz="800" i="0" b="0">
                   <a:solidFill>
                     <a:srgbClr val="262626">
                       <a:alpha val="100000"/>
@@ -7441,8 +7441,8 @@
           </p:nvSpPr>
           <p:spPr>
             <a:xfrm>
-              <a:off x="7012275" y="1900474"/>
-              <a:ext cx="126827" cy="65379"/>
+              <a:off x="5390462" y="1677710"/>
+              <a:ext cx="141274" cy="72786"/>
             </a:xfrm>
             <a:prstGeom prst="rect">
               <a:avLst/>
@@ -7462,7 +7462,7 @@
                 </a:spcAft>
               </a:pPr>
               <a:r>
-                <a:rPr sz="720" i="0" b="0">
+                <a:rPr sz="800" i="0" b="0">
                   <a:solidFill>
                     <a:srgbClr val="262626">
                       <a:alpha val="100000"/>
@@ -7484,8 +7484,8 @@
           </p:nvSpPr>
           <p:spPr>
             <a:xfrm>
-              <a:off x="7012275" y="1177120"/>
-              <a:ext cx="126827" cy="65379"/>
+              <a:off x="5390462" y="1092350"/>
+              <a:ext cx="141274" cy="72786"/>
             </a:xfrm>
             <a:prstGeom prst="rect">
               <a:avLst/>
@@ -7505,7 +7505,7 @@
                 </a:spcAft>
               </a:pPr>
               <a:r>
-                <a:rPr sz="720" i="0" b="0">
+                <a:rPr sz="800" i="0" b="0">
                   <a:solidFill>
                     <a:srgbClr val="262626">
                       <a:alpha val="100000"/>
@@ -7527,18 +7527,18 @@
           </p:nvSpPr>
           <p:spPr>
             <a:xfrm>
-              <a:off x="7161877" y="3379873"/>
-              <a:ext cx="28468" cy="0"/>
+              <a:off x="5557042" y="2884825"/>
+              <a:ext cx="31631" cy="0"/>
             </a:xfrm>
             <a:custGeom>
               <a:avLst/>
               <a:pathLst>
-                <a:path w="28468" h="0">
+                <a:path w="31631" h="0">
                   <a:moveTo>
                     <a:pt x="0" y="0"/>
                   </a:moveTo>
                   <a:lnTo>
-                    <a:pt x="28468" y="0"/>
+                    <a:pt x="31631" y="0"/>
                   </a:lnTo>
                 </a:path>
               </a:pathLst>
@@ -7567,18 +7567,18 @@
           </p:nvSpPr>
           <p:spPr>
             <a:xfrm>
-              <a:off x="7161877" y="2656519"/>
-              <a:ext cx="28468" cy="0"/>
+              <a:off x="5557042" y="2299464"/>
+              <a:ext cx="31631" cy="0"/>
             </a:xfrm>
             <a:custGeom>
               <a:avLst/>
               <a:pathLst>
-                <a:path w="28468" h="0">
+                <a:path w="31631" h="0">
                   <a:moveTo>
                     <a:pt x="0" y="0"/>
                   </a:moveTo>
                   <a:lnTo>
-                    <a:pt x="28468" y="0"/>
+                    <a:pt x="31631" y="0"/>
                   </a:lnTo>
                 </a:path>
               </a:pathLst>
@@ -7607,18 +7607,18 @@
           </p:nvSpPr>
           <p:spPr>
             <a:xfrm>
-              <a:off x="7161877" y="1933164"/>
-              <a:ext cx="28468" cy="0"/>
+              <a:off x="5557042" y="1714104"/>
+              <a:ext cx="31631" cy="0"/>
             </a:xfrm>
             <a:custGeom>
               <a:avLst/>
               <a:pathLst>
-                <a:path w="28468" h="0">
+                <a:path w="31631" h="0">
                   <a:moveTo>
                     <a:pt x="0" y="0"/>
                   </a:moveTo>
                   <a:lnTo>
-                    <a:pt x="28468" y="0"/>
+                    <a:pt x="31631" y="0"/>
                   </a:lnTo>
                 </a:path>
               </a:pathLst>
@@ -7647,18 +7647,18 @@
           </p:nvSpPr>
           <p:spPr>
             <a:xfrm>
-              <a:off x="7161877" y="1209810"/>
-              <a:ext cx="28468" cy="0"/>
+              <a:off x="5557042" y="1128743"/>
+              <a:ext cx="31631" cy="0"/>
             </a:xfrm>
             <a:custGeom>
               <a:avLst/>
               <a:pathLst>
-                <a:path w="28468" h="0">
+                <a:path w="31631" h="0">
                   <a:moveTo>
                     <a:pt x="0" y="0"/>
                   </a:moveTo>
                   <a:lnTo>
-                    <a:pt x="28468" y="0"/>
+                    <a:pt x="31631" y="0"/>
                   </a:lnTo>
                 </a:path>
               </a:pathLst>
@@ -7687,18 +7687,18 @@
           </p:nvSpPr>
           <p:spPr>
             <a:xfrm>
-              <a:off x="7190345" y="3509570"/>
-              <a:ext cx="2734675" cy="0"/>
+              <a:off x="5588674" y="2989780"/>
+              <a:ext cx="1879635" cy="0"/>
             </a:xfrm>
             <a:custGeom>
               <a:avLst/>
               <a:pathLst>
-                <a:path w="2734675" h="0">
+                <a:path w="1879635" h="0">
                   <a:moveTo>
                     <a:pt x="0" y="0"/>
                   </a:moveTo>
                   <a:lnTo>
-                    <a:pt x="2734675" y="0"/>
+                    <a:pt x="1879635" y="0"/>
                   </a:lnTo>
                 </a:path>
               </a:pathLst>
@@ -7727,15 +7727,15 @@
           </p:nvSpPr>
           <p:spPr>
             <a:xfrm>
-              <a:off x="7454991" y="3509570"/>
-              <a:ext cx="0" cy="28468"/>
+              <a:off x="5770574" y="2989780"/>
+              <a:ext cx="0" cy="31631"/>
             </a:xfrm>
             <a:custGeom>
               <a:avLst/>
               <a:pathLst>
-                <a:path w="0" h="28468">
+                <a:path w="0" h="31631">
                   <a:moveTo>
-                    <a:pt x="0" y="28468"/>
+                    <a:pt x="0" y="31631"/>
                   </a:moveTo>
                   <a:lnTo>
                     <a:pt x="0" y="0"/>
@@ -7767,15 +7767,15 @@
           </p:nvSpPr>
           <p:spPr>
             <a:xfrm>
-              <a:off x="7896068" y="3509570"/>
-              <a:ext cx="0" cy="28468"/>
+              <a:off x="6073741" y="2989780"/>
+              <a:ext cx="0" cy="31631"/>
             </a:xfrm>
             <a:custGeom>
               <a:avLst/>
               <a:pathLst>
-                <a:path w="0" h="28468">
+                <a:path w="0" h="31631">
                   <a:moveTo>
-                    <a:pt x="0" y="28468"/>
+                    <a:pt x="0" y="31631"/>
                   </a:moveTo>
                   <a:lnTo>
                     <a:pt x="0" y="0"/>
@@ -7807,15 +7807,15 @@
           </p:nvSpPr>
           <p:spPr>
             <a:xfrm>
-              <a:off x="8337144" y="3509570"/>
-              <a:ext cx="0" cy="28468"/>
+              <a:off x="6376908" y="2989780"/>
+              <a:ext cx="0" cy="31631"/>
             </a:xfrm>
             <a:custGeom>
               <a:avLst/>
               <a:pathLst>
-                <a:path w="0" h="28468">
+                <a:path w="0" h="31631">
                   <a:moveTo>
-                    <a:pt x="0" y="28468"/>
+                    <a:pt x="0" y="31631"/>
                   </a:moveTo>
                   <a:lnTo>
                     <a:pt x="0" y="0"/>
@@ -7847,15 +7847,15 @@
           </p:nvSpPr>
           <p:spPr>
             <a:xfrm>
-              <a:off x="8778221" y="3509570"/>
-              <a:ext cx="0" cy="28468"/>
+              <a:off x="6680075" y="2989780"/>
+              <a:ext cx="0" cy="31631"/>
             </a:xfrm>
             <a:custGeom>
               <a:avLst/>
               <a:pathLst>
-                <a:path w="0" h="28468">
+                <a:path w="0" h="31631">
                   <a:moveTo>
-                    <a:pt x="0" y="28468"/>
+                    <a:pt x="0" y="31631"/>
                   </a:moveTo>
                   <a:lnTo>
                     <a:pt x="0" y="0"/>
@@ -7887,15 +7887,15 @@
           </p:nvSpPr>
           <p:spPr>
             <a:xfrm>
-              <a:off x="9219298" y="3509570"/>
-              <a:ext cx="0" cy="28468"/>
+              <a:off x="6983242" y="2989780"/>
+              <a:ext cx="0" cy="31631"/>
             </a:xfrm>
             <a:custGeom>
               <a:avLst/>
               <a:pathLst>
-                <a:path w="0" h="28468">
+                <a:path w="0" h="31631">
                   <a:moveTo>
-                    <a:pt x="0" y="28468"/>
+                    <a:pt x="0" y="31631"/>
                   </a:moveTo>
                   <a:lnTo>
                     <a:pt x="0" y="0"/>
@@ -7927,15 +7927,15 @@
           </p:nvSpPr>
           <p:spPr>
             <a:xfrm>
-              <a:off x="9660375" y="3509570"/>
-              <a:ext cx="0" cy="28468"/>
+              <a:off x="7286409" y="2989780"/>
+              <a:ext cx="0" cy="31631"/>
             </a:xfrm>
             <a:custGeom>
               <a:avLst/>
               <a:pathLst>
-                <a:path w="0" h="28468">
+                <a:path w="0" h="31631">
                   <a:moveTo>
-                    <a:pt x="0" y="28468"/>
+                    <a:pt x="0" y="31631"/>
                   </a:moveTo>
                   <a:lnTo>
                     <a:pt x="0" y="0"/>
@@ -7967,8 +7967,8 @@
           </p:nvSpPr>
           <p:spPr>
             <a:xfrm rot="-1500000">
-              <a:off x="7173869" y="3623137"/>
-              <a:ext cx="309432" cy="65379"/>
+              <a:off x="5457462" y="3116132"/>
+              <a:ext cx="344637" cy="72786"/>
             </a:xfrm>
             <a:prstGeom prst="rect">
               <a:avLst/>
@@ -7988,7 +7988,7 @@
                 </a:spcAft>
               </a:pPr>
               <a:r>
-                <a:rPr sz="720" i="0" b="0">
+                <a:rPr sz="800" i="0" b="0">
                   <a:solidFill>
                     <a:srgbClr val="262626">
                       <a:alpha val="100000"/>
@@ -8010,8 +8010,8 @@
           </p:nvSpPr>
           <p:spPr>
             <a:xfrm rot="-1500000">
-              <a:off x="7187095" y="3717989"/>
-              <a:ext cx="758311" cy="65379"/>
+              <a:off x="5284058" y="3221785"/>
+              <a:ext cx="844631" cy="72786"/>
             </a:xfrm>
             <a:prstGeom prst="rect">
               <a:avLst/>
@@ -8031,7 +8031,7 @@
                 </a:spcAft>
               </a:pPr>
               <a:r>
-                <a:rPr sz="720" i="0" b="0">
+                <a:rPr sz="800" i="0" b="0">
                   <a:solidFill>
                     <a:srgbClr val="262626">
                       <a:alpha val="100000"/>
@@ -8053,8 +8053,8 @@
           </p:nvSpPr>
           <p:spPr>
             <a:xfrm rot="-1500000">
-              <a:off x="7801884" y="3680449"/>
-              <a:ext cx="157093" cy="65379"/>
+              <a:off x="5968677" y="3179737"/>
+              <a:ext cx="175016" cy="72786"/>
             </a:xfrm>
             <a:prstGeom prst="rect">
               <a:avLst/>
@@ -8074,7 +8074,7 @@
                 </a:spcAft>
               </a:pPr>
               <a:r>
-                <a:rPr sz="720" i="0" b="0">
+                <a:rPr sz="800" i="0" b="0">
                   <a:solidFill>
                     <a:srgbClr val="262626">
                       <a:alpha val="100000"/>
@@ -8096,8 +8096,8 @@
           </p:nvSpPr>
           <p:spPr>
             <a:xfrm rot="-1500000">
-              <a:off x="8106835" y="3611872"/>
-              <a:ext cx="256123" cy="65379"/>
+              <a:off x="6120360" y="3103592"/>
+              <a:ext cx="285292" cy="72786"/>
             </a:xfrm>
             <a:prstGeom prst="rect">
               <a:avLst/>
@@ -8117,7 +8117,7 @@
                 </a:spcAft>
               </a:pPr>
               <a:r>
-                <a:rPr sz="720" i="0" b="0">
+                <a:rPr sz="800" i="0" b="0">
                   <a:solidFill>
                     <a:srgbClr val="262626">
                       <a:alpha val="100000"/>
@@ -8139,8 +8139,8 @@
           </p:nvSpPr>
           <p:spPr>
             <a:xfrm rot="-1500000">
-              <a:off x="8127382" y="3705101"/>
-              <a:ext cx="697321" cy="65379"/>
+              <a:off x="5955062" y="3207448"/>
+              <a:ext cx="776782" cy="72786"/>
             </a:xfrm>
             <a:prstGeom prst="rect">
               <a:avLst/>
@@ -8160,7 +8160,7 @@
                 </a:spcAft>
               </a:pPr>
               <a:r>
-                <a:rPr sz="720" i="0" b="0">
+                <a:rPr sz="800" i="0" b="0">
                   <a:solidFill>
                     <a:srgbClr val="262626">
                       <a:alpha val="100000"/>
@@ -8182,8 +8182,8 @@
           </p:nvSpPr>
           <p:spPr>
             <a:xfrm rot="-1500000">
-              <a:off x="8558445" y="3708292"/>
-              <a:ext cx="288858" cy="65379"/>
+              <a:off x="6435299" y="3210710"/>
+              <a:ext cx="321594" cy="72786"/>
             </a:xfrm>
             <a:prstGeom prst="rect">
               <a:avLst/>
@@ -8203,7 +8203,7 @@
                 </a:spcAft>
               </a:pPr>
               <a:r>
-                <a:rPr sz="720" i="0" b="0">
+                <a:rPr sz="800" i="0" b="0">
                   <a:solidFill>
                     <a:srgbClr val="262626">
                       <a:alpha val="100000"/>
@@ -8225,8 +8225,8 @@
           </p:nvSpPr>
           <p:spPr>
             <a:xfrm rot="-1500000">
-              <a:off x="8278315" y="3769424"/>
-              <a:ext cx="1001725" cy="65379"/>
+              <a:off x="5935314" y="3279037"/>
+              <a:ext cx="1115568" cy="72786"/>
             </a:xfrm>
             <a:prstGeom prst="rect">
               <a:avLst/>
@@ -8246,7 +8246,7 @@
                 </a:spcAft>
               </a:pPr>
               <a:r>
-                <a:rPr sz="720" i="0" b="0">
+                <a:rPr sz="800" i="0" b="0">
                   <a:solidFill>
                     <a:srgbClr val="262626">
                       <a:alpha val="100000"/>
@@ -8268,8 +8268,8 @@
           </p:nvSpPr>
           <p:spPr>
             <a:xfrm rot="-1500000">
-              <a:off x="8817704" y="3747629"/>
-              <a:ext cx="898580" cy="65379"/>
+              <a:off x="6347688" y="3254826"/>
+              <a:ext cx="1000993" cy="72786"/>
             </a:xfrm>
             <a:prstGeom prst="rect">
               <a:avLst/>
@@ -8289,7 +8289,7 @@
                 </a:spcAft>
               </a:pPr>
               <a:r>
-                <a:rPr sz="720" i="0" b="0">
+                <a:rPr sz="800" i="0" b="0">
                   <a:solidFill>
                     <a:srgbClr val="262626">
                       <a:alpha val="100000"/>
@@ -8311,8 +8311,8 @@
           </p:nvSpPr>
           <p:spPr>
             <a:xfrm rot="-5400000">
-              <a:off x="6107034" y="2041979"/>
-              <a:ext cx="1623791" cy="81838"/>
+              <a:off x="4383806" y="1789782"/>
+              <a:ext cx="1805665" cy="90982"/>
             </a:xfrm>
             <a:prstGeom prst="rect">
               <a:avLst/>
@@ -8332,7 +8332,7 @@
                 </a:spcAft>
               </a:pPr>
               <a:r>
-                <a:rPr sz="900" i="0" b="0">
+                <a:rPr sz="1000" i="0" b="0">
                   <a:solidFill>
                     <a:srgbClr val="0D0D0D">
                       <a:alpha val="100000"/>
@@ -8354,8 +8354,8 @@
           </p:nvSpPr>
           <p:spPr>
             <a:xfrm>
-              <a:off x="10038894" y="1608783"/>
-              <a:ext cx="1403176" cy="948230"/>
+              <a:off x="7594834" y="1345862"/>
+              <a:ext cx="1561235" cy="978822"/>
             </a:xfrm>
             <a:prstGeom prst="rect">
               <a:avLst/>
@@ -8380,8 +8380,8 @@
           </p:nvSpPr>
           <p:spPr>
             <a:xfrm>
-              <a:off x="10095830" y="1676418"/>
-              <a:ext cx="654893" cy="72786"/>
+              <a:off x="7658097" y="1421104"/>
+              <a:ext cx="736640" cy="81838"/>
             </a:xfrm>
             <a:prstGeom prst="rect">
               <a:avLst/>
@@ -8401,7 +8401,7 @@
                 </a:spcAft>
               </a:pPr>
               <a:r>
-                <a:rPr sz="800" i="0" b="1">
+                <a:rPr sz="900" i="0" b="1">
                   <a:solidFill>
                     <a:srgbClr val="000000">
                       <a:alpha val="100000"/>
@@ -8423,7 +8423,7 @@
           </p:nvSpPr>
           <p:spPr>
             <a:xfrm>
-              <a:off x="10095830" y="1816839"/>
+              <a:off x="7658097" y="1578184"/>
               <a:ext cx="113872" cy="113872"/>
             </a:xfrm>
             <a:prstGeom prst="rect">
@@ -8449,8 +8449,8 @@
           </p:nvSpPr>
           <p:spPr>
             <a:xfrm>
-              <a:off x="10103194" y="1824203"/>
-              <a:ext cx="99145" cy="99145"/>
+              <a:off x="7666279" y="1586366"/>
+              <a:ext cx="97509" cy="97509"/>
             </a:xfrm>
             <a:prstGeom prst="rect">
               <a:avLst/>
@@ -8475,7 +8475,7 @@
           </p:nvSpPr>
           <p:spPr>
             <a:xfrm>
-              <a:off x="10095830" y="1930712"/>
+              <a:off x="7658097" y="1692057"/>
               <a:ext cx="113872" cy="113872"/>
             </a:xfrm>
             <a:prstGeom prst="rect">
@@ -8501,8 +8501,8 @@
           </p:nvSpPr>
           <p:spPr>
             <a:xfrm>
-              <a:off x="10103194" y="1938076"/>
-              <a:ext cx="99145" cy="99145"/>
+              <a:off x="7666279" y="1700239"/>
+              <a:ext cx="97509" cy="97509"/>
             </a:xfrm>
             <a:prstGeom prst="rect">
               <a:avLst/>
@@ -8527,7 +8527,7 @@
           </p:nvSpPr>
           <p:spPr>
             <a:xfrm>
-              <a:off x="10095830" y="2044585"/>
+              <a:off x="7658097" y="1805930"/>
               <a:ext cx="113872" cy="113872"/>
             </a:xfrm>
             <a:prstGeom prst="rect">
@@ -8553,8 +8553,8 @@
           </p:nvSpPr>
           <p:spPr>
             <a:xfrm>
-              <a:off x="10103194" y="2051949"/>
-              <a:ext cx="99145" cy="99145"/>
+              <a:off x="7666279" y="1814111"/>
+              <a:ext cx="97509" cy="97509"/>
             </a:xfrm>
             <a:prstGeom prst="rect">
               <a:avLst/>
@@ -8579,7 +8579,7 @@
           </p:nvSpPr>
           <p:spPr>
             <a:xfrm>
-              <a:off x="10095830" y="2158458"/>
+              <a:off x="7658097" y="1919803"/>
               <a:ext cx="113872" cy="113872"/>
             </a:xfrm>
             <a:prstGeom prst="rect">
@@ -8605,8 +8605,8 @@
           </p:nvSpPr>
           <p:spPr>
             <a:xfrm>
-              <a:off x="10103194" y="2165822"/>
-              <a:ext cx="99145" cy="99145"/>
+              <a:off x="7666279" y="1927984"/>
+              <a:ext cx="97509" cy="97509"/>
             </a:xfrm>
             <a:prstGeom prst="rect">
               <a:avLst/>
@@ -8631,7 +8631,7 @@
           </p:nvSpPr>
           <p:spPr>
             <a:xfrm>
-              <a:off x="10095830" y="2272331"/>
+              <a:off x="7658097" y="2033676"/>
               <a:ext cx="113872" cy="113872"/>
             </a:xfrm>
             <a:prstGeom prst="rect">
@@ -8657,8 +8657,8 @@
           </p:nvSpPr>
           <p:spPr>
             <a:xfrm>
-              <a:off x="10103194" y="2279695"/>
-              <a:ext cx="99145" cy="99145"/>
+              <a:off x="7666279" y="2041857"/>
+              <a:ext cx="97509" cy="97509"/>
             </a:xfrm>
             <a:prstGeom prst="rect">
               <a:avLst/>
@@ -8683,7 +8683,7 @@
           </p:nvSpPr>
           <p:spPr>
             <a:xfrm>
-              <a:off x="10095830" y="2386204"/>
+              <a:off x="7658097" y="2147549"/>
               <a:ext cx="113872" cy="113872"/>
             </a:xfrm>
             <a:prstGeom prst="rect">
@@ -8709,8 +8709,8 @@
           </p:nvSpPr>
           <p:spPr>
             <a:xfrm>
-              <a:off x="10103194" y="2393568"/>
-              <a:ext cx="99145" cy="99145"/>
+              <a:off x="7666279" y="2155730"/>
+              <a:ext cx="97509" cy="97509"/>
             </a:xfrm>
             <a:prstGeom prst="rect">
               <a:avLst/>
@@ -8735,8 +8735,8 @@
           </p:nvSpPr>
           <p:spPr>
             <a:xfrm>
-              <a:off x="10266639" y="1837383"/>
-              <a:ext cx="779617" cy="72786"/>
+              <a:off x="7835233" y="1594201"/>
+              <a:ext cx="876635" cy="81838"/>
             </a:xfrm>
             <a:prstGeom prst="rect">
               <a:avLst/>
@@ -8756,7 +8756,7 @@
                 </a:spcAft>
               </a:pPr>
               <a:r>
-                <a:rPr sz="800" i="0" b="0">
+                <a:rPr sz="900" i="0" b="0">
                   <a:solidFill>
                     <a:srgbClr val="000000">
                       <a:alpha val="100000"/>
@@ -8778,8 +8778,8 @@
           </p:nvSpPr>
           <p:spPr>
             <a:xfrm>
-              <a:off x="10266639" y="1951256"/>
-              <a:ext cx="813450" cy="72786"/>
+              <a:off x="7835233" y="1708074"/>
+              <a:ext cx="914674" cy="81838"/>
             </a:xfrm>
             <a:prstGeom prst="rect">
               <a:avLst/>
@@ -8799,7 +8799,7 @@
                 </a:spcAft>
               </a:pPr>
               <a:r>
-                <a:rPr sz="800" i="0" b="0">
+                <a:rPr sz="900" i="0" b="0">
                   <a:solidFill>
                     <a:srgbClr val="000000">
                       <a:alpha val="100000"/>
@@ -8821,8 +8821,8 @@
           </p:nvSpPr>
           <p:spPr>
             <a:xfrm>
-              <a:off x="10266639" y="2065129"/>
-              <a:ext cx="623346" cy="72786"/>
+              <a:off x="7835233" y="1821947"/>
+              <a:ext cx="700887" cy="81838"/>
             </a:xfrm>
             <a:prstGeom prst="rect">
               <a:avLst/>
@@ -8842,7 +8842,7 @@
                 </a:spcAft>
               </a:pPr>
               <a:r>
-                <a:rPr sz="800" i="0" b="0">
+                <a:rPr sz="900" i="0" b="0">
                   <a:solidFill>
                     <a:srgbClr val="000000">
                       <a:alpha val="100000"/>
@@ -8864,8 +8864,8 @@
           </p:nvSpPr>
           <p:spPr>
             <a:xfrm>
-              <a:off x="10266639" y="2179002"/>
-              <a:ext cx="1118494" cy="72786"/>
+              <a:off x="7835233" y="1935820"/>
+              <a:ext cx="1257574" cy="81838"/>
             </a:xfrm>
             <a:prstGeom prst="rect">
               <a:avLst/>
@@ -8885,7 +8885,7 @@
                 </a:spcAft>
               </a:pPr>
               <a:r>
-                <a:rPr sz="800" i="0" b="0">
+                <a:rPr sz="900" i="0" b="0">
                   <a:solidFill>
                     <a:srgbClr val="000000">
                       <a:alpha val="100000"/>
@@ -8907,8 +8907,8 @@
           </p:nvSpPr>
           <p:spPr>
             <a:xfrm>
-              <a:off x="10266639" y="2292875"/>
-              <a:ext cx="1112550" cy="72786"/>
+              <a:off x="7835233" y="2049693"/>
+              <a:ext cx="1251264" cy="81838"/>
             </a:xfrm>
             <a:prstGeom prst="rect">
               <a:avLst/>
@@ -8928,7 +8928,7 @@
                 </a:spcAft>
               </a:pPr>
               <a:r>
-                <a:rPr sz="800" i="0" b="0">
+                <a:rPr sz="900" i="0" b="0">
                   <a:solidFill>
                     <a:srgbClr val="000000">
                       <a:alpha val="100000"/>
@@ -8950,8 +8950,8 @@
           </p:nvSpPr>
           <p:spPr>
             <a:xfrm>
-              <a:off x="10266639" y="2406748"/>
-              <a:ext cx="992306" cy="72786"/>
+              <a:off x="7835233" y="2163566"/>
+              <a:ext cx="1115659" cy="81838"/>
             </a:xfrm>
             <a:prstGeom prst="rect">
               <a:avLst/>
@@ -8971,7 +8971,7 @@
                 </a:spcAft>
               </a:pPr>
               <a:r>
-                <a:rPr sz="800" i="0" b="0">
+                <a:rPr sz="900" i="0" b="0">
                   <a:solidFill>
                     <a:srgbClr val="000000">
                       <a:alpha val="100000"/>
@@ -8993,8 +8993,8 @@
           </p:nvSpPr>
           <p:spPr>
             <a:xfrm>
-              <a:off x="7190345" y="503004"/>
-              <a:ext cx="1485168" cy="74432"/>
+              <a:off x="5588674" y="509330"/>
+              <a:ext cx="1667408" cy="83576"/>
             </a:xfrm>
             <a:prstGeom prst="rect">
               <a:avLst/>
@@ -9014,7 +9014,7 @@
                 </a:spcAft>
               </a:pPr>
               <a:r>
-                <a:rPr sz="819" i="0" b="0">
+                <a:rPr sz="919" i="0" b="0">
                   <a:solidFill>
                     <a:srgbClr val="4D4D4D">
                       <a:alpha val="100000"/>
@@ -9036,7 +9036,7 @@
           </p:nvSpPr>
           <p:spPr>
             <a:xfrm>
-              <a:off x="7190345" y="328384"/>
+              <a:off x="5588674" y="328384"/>
               <a:ext cx="1108710" cy="90982"/>
             </a:xfrm>
             <a:prstGeom prst="rect">
@@ -9079,8 +9079,8 @@
           </p:nvSpPr>
           <p:spPr>
             <a:xfrm>
-              <a:off x="6858449" y="329779"/>
-              <a:ext cx="84764" cy="109179"/>
+              <a:off x="5214820" y="318395"/>
+              <a:ext cx="91805" cy="118231"/>
             </a:xfrm>
             <a:prstGeom prst="rect">
               <a:avLst/>
@@ -9100,7 +9100,7 @@
                 </a:spcAft>
               </a:pPr>
               <a:r>
-                <a:rPr sz="1200" i="0" b="1">
+                <a:rPr sz="1300" i="0" b="1">
                   <a:solidFill>
                     <a:srgbClr val="000000">
                       <a:alpha val="100000"/>

</xml_diff>